<commit_message>
Add Pandas_basics.ipynb to Module 5; include pending file updates
Co-authored-by: Cursor <cursoragent@cursor.com>
</commit_message>
<xml_diff>
--- a/module3/module3_MarketMechanism and OOP.pptx
+++ b/module3/module3_MarketMechanism and OOP.pptx
@@ -38,14 +38,14 @@
     <p:sldId id="279" r:id="rId29"/>
     <p:sldId id="290" r:id="rId30"/>
     <p:sldId id="280" r:id="rId31"/>
-    <p:sldId id="281" r:id="rId32"/>
-    <p:sldId id="282" r:id="rId33"/>
-    <p:sldId id="292" r:id="rId34"/>
-    <p:sldId id="296" r:id="rId35"/>
-    <p:sldId id="297" r:id="rId36"/>
-    <p:sldId id="298" r:id="rId37"/>
-    <p:sldId id="299" r:id="rId38"/>
-    <p:sldId id="301" r:id="rId39"/>
+    <p:sldId id="292" r:id="rId32"/>
+    <p:sldId id="296" r:id="rId33"/>
+    <p:sldId id="297" r:id="rId34"/>
+    <p:sldId id="298" r:id="rId35"/>
+    <p:sldId id="299" r:id="rId36"/>
+    <p:sldId id="301" r:id="rId37"/>
+    <p:sldId id="281" r:id="rId38"/>
+    <p:sldId id="282" r:id="rId39"/>
   </p:sldIdLst>
   <p:sldSz cx="9144000" cy="6858000" type="screen4x3"/>
   <p:notesSz cx="9144000" cy="6858000"/>
@@ -842,7 +842,7 @@
           <a:p>
             <a:fld id="{2F65E293-FF06-014D-B54D-ED39F09C8F63}" type="datetimeFigureOut">
               <a:rPr lang="en-US" smtClean="0"/>
-              <a:t>7/4/26</a:t>
+              <a:t>7/6/26</a:t>
             </a:fld>
             <a:endParaRPr lang="en-US"/>
           </a:p>
@@ -3417,7 +3417,7 @@
     </p:spTree>
     <p:extLst>
       <p:ext uri="{BB962C8B-B14F-4D97-AF65-F5344CB8AC3E}">
-        <p14:creationId xmlns:p14="http://schemas.microsoft.com/office/powerpoint/2010/main" val="3908789815"/>
+        <p14:creationId xmlns:p14="http://schemas.microsoft.com/office/powerpoint/2010/main" val="1764460500"/>
       </p:ext>
     </p:extLst>
   </p:cSld>
@@ -3428,201 +3428,6 @@
 </file>
 
 <file path=ppt/notesSlides/notesSlide32.xml><?xml version="1.0" encoding="utf-8"?>
-<p:notes xmlns:a="http://schemas.openxmlformats.org/drawingml/2006/main" xmlns:r="http://schemas.openxmlformats.org/officeDocument/2006/relationships" xmlns:p="http://schemas.openxmlformats.org/presentationml/2006/main">
-  <p:cSld>
-    <p:spTree>
-      <p:nvGrpSpPr>
-        <p:cNvPr id="1" name=""/>
-        <p:cNvGrpSpPr/>
-        <p:nvPr/>
-      </p:nvGrpSpPr>
-      <p:grpSpPr>
-        <a:xfrm>
-          <a:off x="0" y="0"/>
-          <a:ext cx="0" cy="0"/>
-          <a:chOff x="0" y="0"/>
-          <a:chExt cx="0" cy="0"/>
-        </a:xfrm>
-      </p:grpSpPr>
-      <p:sp>
-        <p:nvSpPr>
-          <p:cNvPr id="2" name="Slide Image Placeholder 1"/>
-          <p:cNvSpPr>
-            <a:spLocks noGrp="1" noRot="1" noChangeAspect="1"/>
-          </p:cNvSpPr>
-          <p:nvPr>
-            <p:ph type="sldImg"/>
-          </p:nvPr>
-        </p:nvSpPr>
-        <p:spPr/>
-      </p:sp>
-      <p:sp>
-        <p:nvSpPr>
-          <p:cNvPr id="3" name="Notes Placeholder 2"/>
-          <p:cNvSpPr>
-            <a:spLocks noGrp="1"/>
-          </p:cNvSpPr>
-          <p:nvPr>
-            <p:ph type="body" idx="1"/>
-          </p:nvPr>
-        </p:nvSpPr>
-        <p:spPr/>
-        <p:txBody>
-          <a:bodyPr/>
-          <a:lstStyle/>
-          <a:p>
-            <a:r>
-              <a:rPr lang="en-US" dirty="0"/>
-              <a:t>Unlike traditional macroeconomic models that rely on broad equations, ABM takes a bottom-up approach, focusing on individual decision-making and interactions.</a:t>
-            </a:r>
-          </a:p>
-          <a:p>
-            <a:r>
-              <a:rPr lang="en-US" dirty="0"/>
-              <a:t>In an Agent-Based Model, we simulate an economy as a system of interacting agents, such as consumers, firms, or even policymakers. Each agent follows a set of predefined rules, responding to changes in the environment and interacting with others dynamically. This allows us to observe complex behaviors that emerge naturally from individual actions, rather than assuming equilibrium conditions from the start.</a:t>
-            </a:r>
-          </a:p>
-          <a:p>
-            <a:r>
-              <a:rPr lang="en-US" dirty="0"/>
-              <a:t>For example, if we wanted to study consumer spending behavior, we could model each consumer as an independent agent with income, preferences, and decision-making rules. Over time, we would see how different economic policies, such as stimulus checks or tax changes, influence consumer spending patterns. Similarly, firms can be modeled as agents competing in a market, adjusting their prices and production levels based on demand and competitor behavior. This makes ABM a powerful tool for studying market evolution, financial crises, and the effects of regulation.</a:t>
-            </a:r>
-          </a:p>
-          <a:p>
-            <a:r>
-              <a:rPr lang="en-US" dirty="0"/>
-              <a:t>Ultimately, Agent-Based Modeling helps us understand economic interactions in a way that traditional models cannot. It allows researchers and policymakers to test different scenarios and explore the unexpected consequences of economic decisions. By embracing a computational approach, we can analyze dynamic, adaptive systems in a way that is more reflective of real-world economies.</a:t>
-            </a:r>
-          </a:p>
-          <a:p>
-            <a:endParaRPr lang="en-US" dirty="0"/>
-          </a:p>
-          <a:p>
-            <a:endParaRPr lang="en-US" dirty="0"/>
-          </a:p>
-        </p:txBody>
-      </p:sp>
-      <p:sp>
-        <p:nvSpPr>
-          <p:cNvPr id="4" name="Slide Number Placeholder 3"/>
-          <p:cNvSpPr>
-            <a:spLocks noGrp="1"/>
-          </p:cNvSpPr>
-          <p:nvPr>
-            <p:ph type="sldNum" sz="quarter" idx="5"/>
-          </p:nvPr>
-        </p:nvSpPr>
-        <p:spPr/>
-        <p:txBody>
-          <a:bodyPr/>
-          <a:lstStyle/>
-          <a:p>
-            <a:fld id="{ADDE9FBA-CA5C-0548-A381-56276BA9F0AE}" type="slidenum">
-              <a:rPr lang="en-US" smtClean="0"/>
-              <a:t>32</a:t>
-            </a:fld>
-            <a:endParaRPr lang="en-US"/>
-          </a:p>
-        </p:txBody>
-      </p:sp>
-    </p:spTree>
-    <p:extLst>
-      <p:ext uri="{BB962C8B-B14F-4D97-AF65-F5344CB8AC3E}">
-        <p14:creationId xmlns:p14="http://schemas.microsoft.com/office/powerpoint/2010/main" val="87825393"/>
-      </p:ext>
-    </p:extLst>
-  </p:cSld>
-  <p:clrMapOvr>
-    <a:masterClrMapping/>
-  </p:clrMapOvr>
-</p:notes>
-</file>
-
-<file path=ppt/notesSlides/notesSlide33.xml><?xml version="1.0" encoding="utf-8"?>
-<p:notes xmlns:a="http://schemas.openxmlformats.org/drawingml/2006/main" xmlns:r="http://schemas.openxmlformats.org/officeDocument/2006/relationships" xmlns:p="http://schemas.openxmlformats.org/presentationml/2006/main">
-  <p:cSld>
-    <p:spTree>
-      <p:nvGrpSpPr>
-        <p:cNvPr id="1" name=""/>
-        <p:cNvGrpSpPr/>
-        <p:nvPr/>
-      </p:nvGrpSpPr>
-      <p:grpSpPr>
-        <a:xfrm>
-          <a:off x="0" y="0"/>
-          <a:ext cx="0" cy="0"/>
-          <a:chOff x="0" y="0"/>
-          <a:chExt cx="0" cy="0"/>
-        </a:xfrm>
-      </p:grpSpPr>
-      <p:sp>
-        <p:nvSpPr>
-          <p:cNvPr id="2" name="Slide Image Placeholder 1"/>
-          <p:cNvSpPr>
-            <a:spLocks noGrp="1" noRot="1" noChangeAspect="1"/>
-          </p:cNvSpPr>
-          <p:nvPr>
-            <p:ph type="sldImg"/>
-          </p:nvPr>
-        </p:nvSpPr>
-        <p:spPr/>
-      </p:sp>
-      <p:sp>
-        <p:nvSpPr>
-          <p:cNvPr id="3" name="Notes Placeholder 2"/>
-          <p:cNvSpPr>
-            <a:spLocks noGrp="1"/>
-          </p:cNvSpPr>
-          <p:nvPr>
-            <p:ph type="body" idx="1"/>
-          </p:nvPr>
-        </p:nvSpPr>
-        <p:spPr/>
-        <p:txBody>
-          <a:bodyPr/>
-          <a:lstStyle/>
-          <a:p>
-            <a:endParaRPr lang="en-US" dirty="0"/>
-          </a:p>
-        </p:txBody>
-      </p:sp>
-      <p:sp>
-        <p:nvSpPr>
-          <p:cNvPr id="4" name="Slide Number Placeholder 3"/>
-          <p:cNvSpPr>
-            <a:spLocks noGrp="1"/>
-          </p:cNvSpPr>
-          <p:nvPr>
-            <p:ph type="sldNum" sz="quarter" idx="5"/>
-          </p:nvPr>
-        </p:nvSpPr>
-        <p:spPr/>
-        <p:txBody>
-          <a:bodyPr/>
-          <a:lstStyle/>
-          <a:p>
-            <a:fld id="{ADDE9FBA-CA5C-0548-A381-56276BA9F0AE}" type="slidenum">
-              <a:rPr lang="en-US" smtClean="0"/>
-              <a:t>33</a:t>
-            </a:fld>
-            <a:endParaRPr lang="en-US"/>
-          </a:p>
-        </p:txBody>
-      </p:sp>
-    </p:spTree>
-    <p:extLst>
-      <p:ext uri="{BB962C8B-B14F-4D97-AF65-F5344CB8AC3E}">
-        <p14:creationId xmlns:p14="http://schemas.microsoft.com/office/powerpoint/2010/main" val="1764460500"/>
-      </p:ext>
-    </p:extLst>
-  </p:cSld>
-  <p:clrMapOvr>
-    <a:masterClrMapping/>
-  </p:clrMapOvr>
-</p:notes>
-</file>
-
-<file path=ppt/notesSlides/notesSlide34.xml><?xml version="1.0" encoding="utf-8"?>
 <p:notes xmlns:a="http://schemas.openxmlformats.org/drawingml/2006/main" xmlns:r="http://schemas.openxmlformats.org/officeDocument/2006/relationships" xmlns:p="http://schemas.openxmlformats.org/presentationml/2006/main">
   <p:cSld>
     <p:spTree>
@@ -3718,7 +3523,7 @@
           <a:p>
             <a:fld id="{ADDE9FBA-CA5C-0548-A381-56276BA9F0AE}" type="slidenum">
               <a:rPr lang="en-US" smtClean="0"/>
-              <a:t>34</a:t>
+              <a:t>32</a:t>
             </a:fld>
             <a:endParaRPr lang="en-US"/>
           </a:p>
@@ -3737,7 +3542,7 @@
 </p:notes>
 </file>
 
-<file path=ppt/notesSlides/notesSlide35.xml><?xml version="1.0" encoding="utf-8"?>
+<file path=ppt/notesSlides/notesSlide33.xml><?xml version="1.0" encoding="utf-8"?>
 <p:notes xmlns:a="http://schemas.openxmlformats.org/drawingml/2006/main" xmlns:r="http://schemas.openxmlformats.org/officeDocument/2006/relationships" xmlns:p="http://schemas.openxmlformats.org/presentationml/2006/main">
   <p:cSld>
     <p:spTree>
@@ -3861,7 +3666,7 @@
           <a:p>
             <a:fld id="{ADDE9FBA-CA5C-0548-A381-56276BA9F0AE}" type="slidenum">
               <a:rPr lang="en-US" smtClean="0"/>
-              <a:t>35</a:t>
+              <a:t>33</a:t>
             </a:fld>
             <a:endParaRPr lang="en-US"/>
           </a:p>
@@ -3880,7 +3685,7 @@
 </p:notes>
 </file>
 
-<file path=ppt/notesSlides/notesSlide36.xml><?xml version="1.0" encoding="utf-8"?>
+<file path=ppt/notesSlides/notesSlide34.xml><?xml version="1.0" encoding="utf-8"?>
 <p:notes xmlns:a="http://schemas.openxmlformats.org/drawingml/2006/main" xmlns:r="http://schemas.openxmlformats.org/officeDocument/2006/relationships" xmlns:p="http://schemas.openxmlformats.org/presentationml/2006/main">
   <p:cSld>
     <p:spTree>
@@ -4011,7 +3816,7 @@
           <a:p>
             <a:fld id="{ADDE9FBA-CA5C-0548-A381-56276BA9F0AE}" type="slidenum">
               <a:rPr lang="en-US" smtClean="0"/>
-              <a:t>36</a:t>
+              <a:t>34</a:t>
             </a:fld>
             <a:endParaRPr lang="en-US"/>
           </a:p>
@@ -4030,7 +3835,7 @@
 </p:notes>
 </file>
 
-<file path=ppt/notesSlides/notesSlide37.xml><?xml version="1.0" encoding="utf-8"?>
+<file path=ppt/notesSlides/notesSlide35.xml><?xml version="1.0" encoding="utf-8"?>
 <p:notes xmlns:a="http://schemas.openxmlformats.org/drawingml/2006/main" xmlns:r="http://schemas.openxmlformats.org/officeDocument/2006/relationships" xmlns:p="http://schemas.openxmlformats.org/presentationml/2006/main">
   <p:cSld>
     <p:spTree>
@@ -4145,7 +3950,7 @@
           <a:p>
             <a:fld id="{ADDE9FBA-CA5C-0548-A381-56276BA9F0AE}" type="slidenum">
               <a:rPr lang="en-US" smtClean="0"/>
-              <a:t>37</a:t>
+              <a:t>35</a:t>
             </a:fld>
             <a:endParaRPr lang="en-US"/>
           </a:p>
@@ -4155,6 +3960,174 @@
     <p:extLst>
       <p:ext uri="{BB962C8B-B14F-4D97-AF65-F5344CB8AC3E}">
         <p14:creationId xmlns:p14="http://schemas.microsoft.com/office/powerpoint/2010/main" val="2346695010"/>
+      </p:ext>
+    </p:extLst>
+  </p:cSld>
+  <p:clrMapOvr>
+    <a:masterClrMapping/>
+  </p:clrMapOvr>
+</p:notes>
+</file>
+
+<file path=ppt/notesSlides/notesSlide36.xml><?xml version="1.0" encoding="utf-8"?>
+<p:notes xmlns:a="http://schemas.openxmlformats.org/drawingml/2006/main" xmlns:r="http://schemas.openxmlformats.org/officeDocument/2006/relationships" xmlns:p="http://schemas.openxmlformats.org/presentationml/2006/main">
+  <p:cSld>
+    <p:spTree>
+      <p:nvGrpSpPr>
+        <p:cNvPr id="1" name=""/>
+        <p:cNvGrpSpPr/>
+        <p:nvPr/>
+      </p:nvGrpSpPr>
+      <p:grpSpPr>
+        <a:xfrm>
+          <a:off x="0" y="0"/>
+          <a:ext cx="0" cy="0"/>
+          <a:chOff x="0" y="0"/>
+          <a:chExt cx="0" cy="0"/>
+        </a:xfrm>
+      </p:grpSpPr>
+      <p:sp>
+        <p:nvSpPr>
+          <p:cNvPr id="2" name="Slide Image Placeholder 1"/>
+          <p:cNvSpPr>
+            <a:spLocks noGrp="1" noRot="1" noChangeAspect="1"/>
+          </p:cNvSpPr>
+          <p:nvPr>
+            <p:ph type="sldImg"/>
+          </p:nvPr>
+        </p:nvSpPr>
+        <p:spPr/>
+      </p:sp>
+      <p:sp>
+        <p:nvSpPr>
+          <p:cNvPr id="3" name="Notes Placeholder 2"/>
+          <p:cNvSpPr>
+            <a:spLocks noGrp="1"/>
+          </p:cNvSpPr>
+          <p:nvPr>
+            <p:ph type="body" idx="1"/>
+          </p:nvPr>
+        </p:nvSpPr>
+        <p:spPr/>
+        <p:txBody>
+          <a:bodyPr/>
+          <a:lstStyle/>
+          <a:p>
+            <a:endParaRPr lang="en-US" dirty="0"/>
+          </a:p>
+        </p:txBody>
+      </p:sp>
+      <p:sp>
+        <p:nvSpPr>
+          <p:cNvPr id="4" name="Slide Number Placeholder 3"/>
+          <p:cNvSpPr>
+            <a:spLocks noGrp="1"/>
+          </p:cNvSpPr>
+          <p:nvPr>
+            <p:ph type="sldNum" sz="quarter" idx="5"/>
+          </p:nvPr>
+        </p:nvSpPr>
+        <p:spPr/>
+        <p:txBody>
+          <a:bodyPr/>
+          <a:lstStyle/>
+          <a:p>
+            <a:fld id="{ADDE9FBA-CA5C-0548-A381-56276BA9F0AE}" type="slidenum">
+              <a:rPr lang="en-US" smtClean="0"/>
+              <a:t>36</a:t>
+            </a:fld>
+            <a:endParaRPr lang="en-US"/>
+          </a:p>
+        </p:txBody>
+      </p:sp>
+    </p:spTree>
+    <p:extLst>
+      <p:ext uri="{BB962C8B-B14F-4D97-AF65-F5344CB8AC3E}">
+        <p14:creationId xmlns:p14="http://schemas.microsoft.com/office/powerpoint/2010/main" val="438351347"/>
+      </p:ext>
+    </p:extLst>
+  </p:cSld>
+  <p:clrMapOvr>
+    <a:masterClrMapping/>
+  </p:clrMapOvr>
+</p:notes>
+</file>
+
+<file path=ppt/notesSlides/notesSlide37.xml><?xml version="1.0" encoding="utf-8"?>
+<p:notes xmlns:a="http://schemas.openxmlformats.org/drawingml/2006/main" xmlns:r="http://schemas.openxmlformats.org/officeDocument/2006/relationships" xmlns:p="http://schemas.openxmlformats.org/presentationml/2006/main">
+  <p:cSld>
+    <p:spTree>
+      <p:nvGrpSpPr>
+        <p:cNvPr id="1" name=""/>
+        <p:cNvGrpSpPr/>
+        <p:nvPr/>
+      </p:nvGrpSpPr>
+      <p:grpSpPr>
+        <a:xfrm>
+          <a:off x="0" y="0"/>
+          <a:ext cx="0" cy="0"/>
+          <a:chOff x="0" y="0"/>
+          <a:chExt cx="0" cy="0"/>
+        </a:xfrm>
+      </p:grpSpPr>
+      <p:sp>
+        <p:nvSpPr>
+          <p:cNvPr id="2" name="Slide Image Placeholder 1"/>
+          <p:cNvSpPr>
+            <a:spLocks noGrp="1" noRot="1" noChangeAspect="1"/>
+          </p:cNvSpPr>
+          <p:nvPr>
+            <p:ph type="sldImg"/>
+          </p:nvPr>
+        </p:nvSpPr>
+        <p:spPr/>
+      </p:sp>
+      <p:sp>
+        <p:nvSpPr>
+          <p:cNvPr id="3" name="Notes Placeholder 2"/>
+          <p:cNvSpPr>
+            <a:spLocks noGrp="1"/>
+          </p:cNvSpPr>
+          <p:nvPr>
+            <p:ph type="body" idx="1"/>
+          </p:nvPr>
+        </p:nvSpPr>
+        <p:spPr/>
+        <p:txBody>
+          <a:bodyPr/>
+          <a:lstStyle/>
+          <a:p>
+            <a:endParaRPr lang="en-US" dirty="0"/>
+          </a:p>
+        </p:txBody>
+      </p:sp>
+      <p:sp>
+        <p:nvSpPr>
+          <p:cNvPr id="4" name="Slide Number Placeholder 3"/>
+          <p:cNvSpPr>
+            <a:spLocks noGrp="1"/>
+          </p:cNvSpPr>
+          <p:nvPr>
+            <p:ph type="sldNum" sz="quarter" idx="5"/>
+          </p:nvPr>
+        </p:nvSpPr>
+        <p:spPr/>
+        <p:txBody>
+          <a:bodyPr/>
+          <a:lstStyle/>
+          <a:p>
+            <a:fld id="{ADDE9FBA-CA5C-0548-A381-56276BA9F0AE}" type="slidenum">
+              <a:rPr lang="en-US" smtClean="0"/>
+              <a:t>37</a:t>
+            </a:fld>
+            <a:endParaRPr lang="en-US"/>
+          </a:p>
+        </p:txBody>
+      </p:sp>
+    </p:spTree>
+    <p:extLst>
+      <p:ext uri="{BB962C8B-B14F-4D97-AF65-F5344CB8AC3E}">
+        <p14:creationId xmlns:p14="http://schemas.microsoft.com/office/powerpoint/2010/main" val="1642339734"/>
       </p:ext>
     </p:extLst>
   </p:cSld>
@@ -4208,6 +4181,33 @@
           <a:bodyPr/>
           <a:lstStyle/>
           <a:p>
+            <a:r>
+              <a:rPr lang="en-US" dirty="0"/>
+              <a:t>Unlike traditional macroeconomic models that rely on broad equations, ABM takes a bottom-up approach, focusing on individual decision-making and interactions.</a:t>
+            </a:r>
+          </a:p>
+          <a:p>
+            <a:r>
+              <a:rPr lang="en-US" dirty="0"/>
+              <a:t>In an Agent-Based Model, we simulate an economy as a system of interacting agents, such as consumers, firms, or even policymakers. Each agent follows a set of predefined rules, responding to changes in the environment and interacting with others dynamically. This allows us to observe complex behaviors that emerge naturally from individual actions, rather than assuming equilibrium conditions from the start.</a:t>
+            </a:r>
+          </a:p>
+          <a:p>
+            <a:r>
+              <a:rPr lang="en-US" dirty="0"/>
+              <a:t>For example, if we wanted to study consumer spending behavior, we could model each consumer as an independent agent with income, preferences, and decision-making rules. Over time, we would see how different economic policies, such as stimulus checks or tax changes, influence consumer spending patterns. Similarly, firms can be modeled as agents competing in a market, adjusting their prices and production levels based on demand and competitor behavior. This makes ABM a powerful tool for studying market evolution, financial crises, and the effects of regulation.</a:t>
+            </a:r>
+          </a:p>
+          <a:p>
+            <a:r>
+              <a:rPr lang="en-US" dirty="0"/>
+              <a:t>Ultimately, Agent-Based Modeling helps us understand economic interactions in a way that traditional models cannot. It allows researchers and policymakers to test different scenarios and explore the unexpected consequences of economic decisions. By embracing a computational approach, we can analyze dynamic, adaptive systems in a way that is more reflective of real-world economies.</a:t>
+            </a:r>
+          </a:p>
+          <a:p>
+            <a:endParaRPr lang="en-US" dirty="0"/>
+          </a:p>
+          <a:p>
             <a:endParaRPr lang="en-US" dirty="0"/>
           </a:p>
         </p:txBody>
@@ -4238,7 +4238,7 @@
     </p:spTree>
     <p:extLst>
       <p:ext uri="{BB962C8B-B14F-4D97-AF65-F5344CB8AC3E}">
-        <p14:creationId xmlns:p14="http://schemas.microsoft.com/office/powerpoint/2010/main" val="438351347"/>
+        <p14:creationId xmlns:p14="http://schemas.microsoft.com/office/powerpoint/2010/main" val="1673058463"/>
       </p:ext>
     </p:extLst>
   </p:cSld>
@@ -4897,7 +4897,7 @@
           <a:p>
             <a:fld id="{1D8BD707-D9CF-40AE-B4C6-C98DA3205C09}" type="datetimeFigureOut">
               <a:rPr lang="en-US"/>
-              <a:t>7/4/26</a:t>
+              <a:t>7/6/26</a:t>
             </a:fld>
             <a:endParaRPr lang="en-US"/>
           </a:p>
@@ -5088,7 +5088,7 @@
           <a:p>
             <a:fld id="{1D8BD707-D9CF-40AE-B4C6-C98DA3205C09}" type="datetimeFigureOut">
               <a:rPr lang="en-US"/>
-              <a:t>7/4/26</a:t>
+              <a:t>7/6/26</a:t>
             </a:fld>
             <a:endParaRPr lang="en-US"/>
           </a:p>
@@ -5316,7 +5316,7 @@
           <a:p>
             <a:fld id="{1D8BD707-D9CF-40AE-B4C6-C98DA3205C09}" type="datetimeFigureOut">
               <a:rPr lang="en-US"/>
-              <a:t>7/4/26</a:t>
+              <a:t>7/6/26</a:t>
             </a:fld>
             <a:endParaRPr lang="en-US"/>
           </a:p>
@@ -5594,7 +5594,7 @@
           <a:p>
             <a:fld id="{1D8BD707-D9CF-40AE-B4C6-C98DA3205C09}" type="datetimeFigureOut">
               <a:rPr lang="en-US"/>
-              <a:t>7/4/26</a:t>
+              <a:t>7/6/26</a:t>
             </a:fld>
             <a:endParaRPr lang="en-US"/>
           </a:p>
@@ -5727,7 +5727,7 @@
           <a:p>
             <a:fld id="{1D8BD707-D9CF-40AE-B4C6-C98DA3205C09}" type="datetimeFigureOut">
               <a:rPr lang="en-US"/>
-              <a:t>7/4/26</a:t>
+              <a:t>7/6/26</a:t>
             </a:fld>
             <a:endParaRPr lang="en-US"/>
           </a:p>
@@ -5959,7 +5959,7 @@
           <a:p>
             <a:fld id="{1D8BD707-D9CF-40AE-B4C6-C98DA3205C09}" type="datetimeFigureOut">
               <a:rPr lang="en-US" smtClean="0"/>
-              <a:t>7/4/26</a:t>
+              <a:t>7/6/26</a:t>
             </a:fld>
             <a:endParaRPr lang="en-US"/>
           </a:p>
@@ -6263,7 +6263,7 @@
           <a:p>
             <a:fld id="{1D8BD707-D9CF-40AE-B4C6-C98DA3205C09}" type="datetimeFigureOut">
               <a:rPr lang="en-US"/>
-              <a:t>7/4/26</a:t>
+              <a:t>7/6/26</a:t>
             </a:fld>
             <a:endParaRPr lang="en-US"/>
           </a:p>
@@ -19170,1529 +19170,6 @@
         </p:nvSpPr>
         <p:spPr>
           <a:xfrm>
-            <a:off x="1282700" y="1821868"/>
-            <a:ext cx="6946900" cy="2998257"/>
-          </a:xfrm>
-          <a:prstGeom prst="rect">
-            <a:avLst/>
-          </a:prstGeom>
-        </p:spPr>
-        <p:txBody>
-          <a:bodyPr vert="horz" wrap="square" lIns="0" tIns="12700" rIns="0" bIns="0" rtlCol="0">
-            <a:spAutoFit/>
-          </a:bodyPr>
-          <a:lstStyle/>
-          <a:p>
-            <a:pPr marL="12700" algn="just">
-              <a:lnSpc>
-                <a:spcPct val="100000"/>
-              </a:lnSpc>
-              <a:spcBef>
-                <a:spcPts val="100"/>
-              </a:spcBef>
-            </a:pPr>
-            <a:r>
-              <a:rPr sz="2400" dirty="0">
-                <a:solidFill>
-                  <a:srgbClr val="231F20"/>
-                </a:solidFill>
-                <a:latin typeface="Arial"/>
-                <a:cs typeface="Arial"/>
-              </a:rPr>
-              <a:t>Application</a:t>
-            </a:r>
-            <a:r>
-              <a:rPr sz="2400" spc="-20" dirty="0">
-                <a:solidFill>
-                  <a:srgbClr val="231F20"/>
-                </a:solidFill>
-                <a:latin typeface="Arial"/>
-                <a:cs typeface="Arial"/>
-              </a:rPr>
-              <a:t> </a:t>
-            </a:r>
-            <a:r>
-              <a:rPr sz="2400" spc="-5" dirty="0">
-                <a:solidFill>
-                  <a:srgbClr val="231F20"/>
-                </a:solidFill>
-                <a:latin typeface="Arial"/>
-                <a:cs typeface="Arial"/>
-              </a:rPr>
-              <a:t>of</a:t>
-            </a:r>
-            <a:r>
-              <a:rPr sz="2400" spc="-20" dirty="0">
-                <a:solidFill>
-                  <a:srgbClr val="231F20"/>
-                </a:solidFill>
-                <a:latin typeface="Arial"/>
-                <a:cs typeface="Arial"/>
-              </a:rPr>
-              <a:t> </a:t>
-            </a:r>
-            <a:r>
-              <a:rPr sz="2400" dirty="0">
-                <a:solidFill>
-                  <a:srgbClr val="231F20"/>
-                </a:solidFill>
-                <a:latin typeface="Arial"/>
-                <a:cs typeface="Arial"/>
-              </a:rPr>
-              <a:t>OOP</a:t>
-            </a:r>
-            <a:r>
-              <a:rPr sz="2400" spc="-65" dirty="0">
-                <a:solidFill>
-                  <a:srgbClr val="231F20"/>
-                </a:solidFill>
-                <a:latin typeface="Arial"/>
-                <a:cs typeface="Arial"/>
-              </a:rPr>
-              <a:t> </a:t>
-            </a:r>
-            <a:r>
-              <a:rPr sz="2400" spc="-5" dirty="0">
-                <a:solidFill>
-                  <a:srgbClr val="231F20"/>
-                </a:solidFill>
-                <a:latin typeface="Arial"/>
-                <a:cs typeface="Arial"/>
-              </a:rPr>
-              <a:t>in</a:t>
-            </a:r>
-            <a:r>
-              <a:rPr sz="2400" spc="-20" dirty="0">
-                <a:solidFill>
-                  <a:srgbClr val="231F20"/>
-                </a:solidFill>
-                <a:latin typeface="Arial"/>
-                <a:cs typeface="Arial"/>
-              </a:rPr>
-              <a:t> </a:t>
-            </a:r>
-            <a:r>
-              <a:rPr sz="2400" spc="-5" dirty="0">
-                <a:solidFill>
-                  <a:srgbClr val="231F20"/>
-                </a:solidFill>
-                <a:latin typeface="Arial"/>
-                <a:cs typeface="Arial"/>
-              </a:rPr>
-              <a:t>economics:</a:t>
-            </a:r>
-            <a:endParaRPr sz="2400" dirty="0">
-              <a:latin typeface="Arial"/>
-              <a:cs typeface="Arial"/>
-            </a:endParaRPr>
-          </a:p>
-          <a:p>
-            <a:pPr>
-              <a:lnSpc>
-                <a:spcPct val="100000"/>
-              </a:lnSpc>
-              <a:spcBef>
-                <a:spcPts val="5"/>
-              </a:spcBef>
-            </a:pPr>
-            <a:endParaRPr sz="2500" dirty="0">
-              <a:latin typeface="Arial"/>
-              <a:cs typeface="Arial"/>
-            </a:endParaRPr>
-          </a:p>
-          <a:p>
-            <a:pPr marL="12700" marR="5080" algn="just">
-              <a:lnSpc>
-                <a:spcPct val="100000"/>
-              </a:lnSpc>
-            </a:pPr>
-            <a:r>
-              <a:rPr sz="2400" dirty="0">
-                <a:solidFill>
-                  <a:srgbClr val="231F20"/>
-                </a:solidFill>
-                <a:latin typeface="Arial"/>
-                <a:cs typeface="Arial"/>
-              </a:rPr>
-              <a:t>Agent-based</a:t>
-            </a:r>
-            <a:r>
-              <a:rPr sz="2400" spc="5" dirty="0">
-                <a:solidFill>
-                  <a:srgbClr val="231F20"/>
-                </a:solidFill>
-                <a:latin typeface="Arial"/>
-                <a:cs typeface="Arial"/>
-              </a:rPr>
-              <a:t> </a:t>
-            </a:r>
-            <a:r>
-              <a:rPr sz="2400" dirty="0">
-                <a:solidFill>
-                  <a:srgbClr val="231F20"/>
-                </a:solidFill>
-                <a:latin typeface="Arial"/>
-                <a:cs typeface="Arial"/>
-              </a:rPr>
-              <a:t>modeling</a:t>
-            </a:r>
-            <a:r>
-              <a:rPr sz="2400" spc="5" dirty="0">
-                <a:solidFill>
-                  <a:srgbClr val="231F20"/>
-                </a:solidFill>
-                <a:latin typeface="Arial"/>
-                <a:cs typeface="Arial"/>
-              </a:rPr>
-              <a:t> </a:t>
-            </a:r>
-            <a:r>
-              <a:rPr sz="2400" dirty="0">
-                <a:solidFill>
-                  <a:srgbClr val="231F20"/>
-                </a:solidFill>
-                <a:latin typeface="Arial"/>
-                <a:cs typeface="Arial"/>
-              </a:rPr>
-              <a:t>(ABM)</a:t>
-            </a:r>
-            <a:r>
-              <a:rPr sz="2400" spc="5" dirty="0">
-                <a:solidFill>
-                  <a:srgbClr val="231F20"/>
-                </a:solidFill>
-                <a:latin typeface="Arial"/>
-                <a:cs typeface="Arial"/>
-              </a:rPr>
-              <a:t> </a:t>
-            </a:r>
-            <a:r>
-              <a:rPr sz="2400" spc="-5" dirty="0">
-                <a:solidFill>
-                  <a:srgbClr val="231F20"/>
-                </a:solidFill>
-                <a:latin typeface="Arial"/>
-                <a:cs typeface="Arial"/>
-              </a:rPr>
-              <a:t>is</a:t>
-            </a:r>
-            <a:r>
-              <a:rPr sz="2400" dirty="0">
-                <a:solidFill>
-                  <a:srgbClr val="231F20"/>
-                </a:solidFill>
-                <a:latin typeface="Arial"/>
-                <a:cs typeface="Arial"/>
-              </a:rPr>
-              <a:t> the</a:t>
-            </a:r>
-            <a:r>
-              <a:rPr sz="2400" spc="5" dirty="0">
-                <a:solidFill>
-                  <a:srgbClr val="231F20"/>
-                </a:solidFill>
-                <a:latin typeface="Arial"/>
-                <a:cs typeface="Arial"/>
-              </a:rPr>
-              <a:t> </a:t>
-            </a:r>
-            <a:r>
-              <a:rPr sz="2400" spc="-5" dirty="0">
-                <a:solidFill>
-                  <a:srgbClr val="231F20"/>
-                </a:solidFill>
-                <a:latin typeface="Arial"/>
-                <a:cs typeface="Arial"/>
-              </a:rPr>
-              <a:t>area</a:t>
-            </a:r>
-            <a:r>
-              <a:rPr sz="2400" dirty="0">
-                <a:solidFill>
-                  <a:srgbClr val="231F20"/>
-                </a:solidFill>
-                <a:latin typeface="Arial"/>
-                <a:cs typeface="Arial"/>
-              </a:rPr>
-              <a:t> </a:t>
-            </a:r>
-            <a:r>
-              <a:rPr sz="2400" spc="-5" dirty="0">
-                <a:solidFill>
-                  <a:srgbClr val="231F20"/>
-                </a:solidFill>
-                <a:latin typeface="Arial"/>
-                <a:cs typeface="Arial"/>
-              </a:rPr>
-              <a:t>of </a:t>
-            </a:r>
-            <a:r>
-              <a:rPr sz="2400" dirty="0">
-                <a:solidFill>
-                  <a:srgbClr val="231F20"/>
-                </a:solidFill>
-                <a:latin typeface="Arial"/>
-                <a:cs typeface="Arial"/>
-              </a:rPr>
-              <a:t> computational</a:t>
-            </a:r>
-            <a:r>
-              <a:rPr sz="2400" spc="5" dirty="0">
-                <a:solidFill>
-                  <a:srgbClr val="231F20"/>
-                </a:solidFill>
-                <a:latin typeface="Arial"/>
-                <a:cs typeface="Arial"/>
-              </a:rPr>
-              <a:t> </a:t>
-            </a:r>
-            <a:r>
-              <a:rPr sz="2400" spc="-5" dirty="0">
-                <a:solidFill>
-                  <a:srgbClr val="231F20"/>
-                </a:solidFill>
-                <a:latin typeface="Arial"/>
-                <a:cs typeface="Arial"/>
-              </a:rPr>
-              <a:t>economics</a:t>
-            </a:r>
-            <a:r>
-              <a:rPr sz="2400" dirty="0">
-                <a:solidFill>
-                  <a:srgbClr val="231F20"/>
-                </a:solidFill>
-                <a:latin typeface="Arial"/>
-                <a:cs typeface="Arial"/>
-              </a:rPr>
-              <a:t> that</a:t>
-            </a:r>
-            <a:r>
-              <a:rPr sz="2400" spc="5" dirty="0">
-                <a:solidFill>
-                  <a:srgbClr val="231F20"/>
-                </a:solidFill>
-                <a:latin typeface="Arial"/>
-                <a:cs typeface="Arial"/>
-              </a:rPr>
-              <a:t> </a:t>
-            </a:r>
-            <a:r>
-              <a:rPr sz="2400" dirty="0">
-                <a:solidFill>
-                  <a:srgbClr val="231F20"/>
-                </a:solidFill>
-                <a:latin typeface="Arial"/>
-                <a:cs typeface="Arial"/>
-              </a:rPr>
-              <a:t>studies</a:t>
-            </a:r>
-            <a:r>
-              <a:rPr sz="2400" spc="5" dirty="0">
-                <a:solidFill>
-                  <a:srgbClr val="231F20"/>
-                </a:solidFill>
-                <a:latin typeface="Arial"/>
-                <a:cs typeface="Arial"/>
-              </a:rPr>
-              <a:t> </a:t>
-            </a:r>
-            <a:r>
-              <a:rPr sz="2400" dirty="0">
-                <a:solidFill>
-                  <a:srgbClr val="231F20"/>
-                </a:solidFill>
-                <a:latin typeface="Arial"/>
-                <a:cs typeface="Arial"/>
-              </a:rPr>
-              <a:t>the </a:t>
-            </a:r>
-            <a:r>
-              <a:rPr sz="2400" spc="5" dirty="0">
-                <a:solidFill>
-                  <a:srgbClr val="231F20"/>
-                </a:solidFill>
-                <a:latin typeface="Arial"/>
-                <a:cs typeface="Arial"/>
-              </a:rPr>
-              <a:t> </a:t>
-            </a:r>
-            <a:r>
-              <a:rPr sz="2400" spc="-5" dirty="0">
-                <a:solidFill>
-                  <a:srgbClr val="231F20"/>
-                </a:solidFill>
-                <a:latin typeface="Arial"/>
-                <a:cs typeface="Arial"/>
-              </a:rPr>
-              <a:t>economi</a:t>
-            </a:r>
-            <a:r>
-              <a:rPr sz="2400" dirty="0">
-                <a:solidFill>
-                  <a:srgbClr val="231F20"/>
-                </a:solidFill>
-                <a:latin typeface="Arial"/>
-                <a:cs typeface="Arial"/>
-              </a:rPr>
-              <a:t>c</a:t>
-            </a:r>
-            <a:r>
-              <a:rPr sz="2400" spc="-409" dirty="0">
-                <a:solidFill>
-                  <a:srgbClr val="231F20"/>
-                </a:solidFill>
-                <a:latin typeface="Arial"/>
-                <a:cs typeface="Arial"/>
-              </a:rPr>
-              <a:t> </a:t>
-            </a:r>
-            <a:r>
-              <a:rPr sz="2400" spc="-5" dirty="0">
-                <a:solidFill>
-                  <a:srgbClr val="231F20"/>
-                </a:solidFill>
-                <a:latin typeface="Arial"/>
-                <a:cs typeface="Arial"/>
-              </a:rPr>
-              <a:t>processes</a:t>
-            </a:r>
-            <a:r>
-              <a:rPr sz="2400" dirty="0">
-                <a:solidFill>
-                  <a:srgbClr val="231F20"/>
-                </a:solidFill>
-                <a:latin typeface="Arial"/>
-                <a:cs typeface="Arial"/>
-              </a:rPr>
-              <a:t>,</a:t>
-            </a:r>
-            <a:r>
-              <a:rPr sz="2400" spc="-409" dirty="0">
-                <a:solidFill>
-                  <a:srgbClr val="231F20"/>
-                </a:solidFill>
-                <a:latin typeface="Arial"/>
-                <a:cs typeface="Arial"/>
-              </a:rPr>
-              <a:t> </a:t>
-            </a:r>
-            <a:r>
-              <a:rPr sz="2400" spc="-5" dirty="0">
-                <a:solidFill>
-                  <a:srgbClr val="231F20"/>
-                </a:solidFill>
-                <a:latin typeface="Arial"/>
-                <a:cs typeface="Arial"/>
-              </a:rPr>
-              <a:t>includin</a:t>
-            </a:r>
-            <a:r>
-              <a:rPr sz="2400" dirty="0">
-                <a:solidFill>
-                  <a:srgbClr val="231F20"/>
-                </a:solidFill>
-                <a:latin typeface="Arial"/>
-                <a:cs typeface="Arial"/>
-              </a:rPr>
-              <a:t>g</a:t>
-            </a:r>
-            <a:r>
-              <a:rPr sz="2400" spc="-409" dirty="0">
-                <a:solidFill>
-                  <a:srgbClr val="231F20"/>
-                </a:solidFill>
-                <a:latin typeface="Arial"/>
-                <a:cs typeface="Arial"/>
-              </a:rPr>
-              <a:t> </a:t>
-            </a:r>
-            <a:r>
-              <a:rPr sz="2400" spc="-5" dirty="0">
-                <a:solidFill>
-                  <a:srgbClr val="231F20"/>
-                </a:solidFill>
-                <a:latin typeface="Arial"/>
-                <a:cs typeface="Arial"/>
-              </a:rPr>
-              <a:t>whol</a:t>
-            </a:r>
-            <a:r>
-              <a:rPr sz="2400" dirty="0">
-                <a:solidFill>
-                  <a:srgbClr val="231F20"/>
-                </a:solidFill>
-                <a:latin typeface="Arial"/>
-                <a:cs typeface="Arial"/>
-              </a:rPr>
-              <a:t>e</a:t>
-            </a:r>
-            <a:r>
-              <a:rPr sz="2400" spc="-409" dirty="0">
-                <a:solidFill>
-                  <a:srgbClr val="231F20"/>
-                </a:solidFill>
-                <a:latin typeface="Arial"/>
-                <a:cs typeface="Arial"/>
-              </a:rPr>
-              <a:t> </a:t>
-            </a:r>
-            <a:r>
-              <a:rPr sz="2400" spc="-5" dirty="0">
-                <a:solidFill>
-                  <a:srgbClr val="231F20"/>
-                </a:solidFill>
-                <a:latin typeface="Arial"/>
-                <a:cs typeface="Arial"/>
-              </a:rPr>
-              <a:t>economies,  as</a:t>
-            </a:r>
-            <a:r>
-              <a:rPr sz="2400" spc="-10" dirty="0">
-                <a:solidFill>
-                  <a:srgbClr val="231F20"/>
-                </a:solidFill>
-                <a:latin typeface="Arial"/>
-                <a:cs typeface="Arial"/>
-              </a:rPr>
-              <a:t> </a:t>
-            </a:r>
-            <a:r>
-              <a:rPr sz="2400" spc="-5" dirty="0">
-                <a:solidFill>
-                  <a:srgbClr val="231F20"/>
-                </a:solidFill>
-                <a:latin typeface="Arial"/>
-                <a:cs typeface="Arial"/>
-              </a:rPr>
-              <a:t>dynamic</a:t>
-            </a:r>
-            <a:r>
-              <a:rPr sz="2400" spc="-10" dirty="0">
-                <a:solidFill>
-                  <a:srgbClr val="231F20"/>
-                </a:solidFill>
-                <a:latin typeface="Arial"/>
-                <a:cs typeface="Arial"/>
-              </a:rPr>
-              <a:t> </a:t>
-            </a:r>
-            <a:r>
-              <a:rPr sz="2400" dirty="0">
-                <a:solidFill>
-                  <a:srgbClr val="231F20"/>
-                </a:solidFill>
-                <a:latin typeface="Arial"/>
-                <a:cs typeface="Arial"/>
-              </a:rPr>
-              <a:t>system</a:t>
-            </a:r>
-            <a:r>
-              <a:rPr sz="2400" spc="-5" dirty="0">
-                <a:solidFill>
-                  <a:srgbClr val="231F20"/>
-                </a:solidFill>
-                <a:latin typeface="Arial"/>
-                <a:cs typeface="Arial"/>
-              </a:rPr>
-              <a:t> of</a:t>
-            </a:r>
-            <a:r>
-              <a:rPr sz="2400" spc="-10" dirty="0">
-                <a:solidFill>
-                  <a:srgbClr val="231F20"/>
-                </a:solidFill>
-                <a:latin typeface="Arial"/>
-                <a:cs typeface="Arial"/>
-              </a:rPr>
-              <a:t> </a:t>
-            </a:r>
-            <a:r>
-              <a:rPr sz="2400" spc="-5" dirty="0">
-                <a:solidFill>
-                  <a:srgbClr val="231F20"/>
-                </a:solidFill>
-                <a:latin typeface="Arial"/>
-                <a:cs typeface="Arial"/>
-              </a:rPr>
-              <a:t>interacting</a:t>
-            </a:r>
-            <a:r>
-              <a:rPr sz="2400" spc="-10" dirty="0">
-                <a:solidFill>
-                  <a:srgbClr val="231F20"/>
-                </a:solidFill>
-                <a:latin typeface="Arial"/>
-                <a:cs typeface="Arial"/>
-              </a:rPr>
-              <a:t> </a:t>
-            </a:r>
-            <a:r>
-              <a:rPr sz="2400" spc="-5" dirty="0">
-                <a:solidFill>
-                  <a:srgbClr val="231F20"/>
-                </a:solidFill>
-                <a:latin typeface="Arial"/>
-                <a:cs typeface="Arial"/>
-              </a:rPr>
-              <a:t>agents.</a:t>
-            </a:r>
-            <a:endParaRPr sz="2400" dirty="0">
-              <a:latin typeface="Arial"/>
-              <a:cs typeface="Arial"/>
-            </a:endParaRPr>
-          </a:p>
-          <a:p>
-            <a:pPr>
-              <a:lnSpc>
-                <a:spcPct val="100000"/>
-              </a:lnSpc>
-              <a:spcBef>
-                <a:spcPts val="5"/>
-              </a:spcBef>
-            </a:pPr>
-            <a:endParaRPr sz="2500" dirty="0">
-              <a:latin typeface="Arial"/>
-              <a:cs typeface="Arial"/>
-            </a:endParaRPr>
-          </a:p>
-          <a:p>
-            <a:pPr marL="12700" algn="just">
-              <a:lnSpc>
-                <a:spcPct val="100000"/>
-              </a:lnSpc>
-            </a:pPr>
-            <a:r>
-              <a:rPr lang="en-US" sz="2400" spc="-5" dirty="0">
-                <a:solidFill>
-                  <a:srgbClr val="231F20"/>
-                </a:solidFill>
-                <a:latin typeface="Arial"/>
-                <a:cs typeface="Arial"/>
-              </a:rPr>
-              <a:t>----</a:t>
-            </a:r>
-            <a:r>
-              <a:rPr sz="2400" spc="-5" dirty="0">
-                <a:solidFill>
-                  <a:srgbClr val="231F20"/>
-                </a:solidFill>
-                <a:latin typeface="Arial"/>
-                <a:cs typeface="Arial"/>
-              </a:rPr>
-              <a:t>Understand</a:t>
-            </a:r>
-            <a:r>
-              <a:rPr sz="2400" spc="-20" dirty="0">
-                <a:solidFill>
-                  <a:srgbClr val="231F20"/>
-                </a:solidFill>
-                <a:latin typeface="Arial"/>
-                <a:cs typeface="Arial"/>
-              </a:rPr>
-              <a:t> </a:t>
-            </a:r>
-            <a:r>
-              <a:rPr sz="2400" dirty="0">
-                <a:solidFill>
-                  <a:srgbClr val="231F20"/>
-                </a:solidFill>
-                <a:latin typeface="Arial"/>
-                <a:cs typeface="Arial"/>
-              </a:rPr>
-              <a:t>the</a:t>
-            </a:r>
-            <a:r>
-              <a:rPr sz="2400" spc="-15" dirty="0">
-                <a:solidFill>
-                  <a:srgbClr val="231F20"/>
-                </a:solidFill>
-                <a:latin typeface="Arial"/>
-                <a:cs typeface="Arial"/>
-              </a:rPr>
-              <a:t> </a:t>
-            </a:r>
-            <a:r>
-              <a:rPr sz="2400" spc="-5" dirty="0">
-                <a:solidFill>
-                  <a:srgbClr val="231F20"/>
-                </a:solidFill>
-                <a:latin typeface="Arial"/>
-                <a:cs typeface="Arial"/>
-              </a:rPr>
-              <a:t>economy</a:t>
-            </a:r>
-            <a:r>
-              <a:rPr sz="2400" spc="-20" dirty="0">
-                <a:solidFill>
-                  <a:srgbClr val="231F20"/>
-                </a:solidFill>
-                <a:latin typeface="Arial"/>
-                <a:cs typeface="Arial"/>
-              </a:rPr>
-              <a:t> </a:t>
-            </a:r>
-            <a:r>
-              <a:rPr sz="2400" dirty="0">
-                <a:solidFill>
-                  <a:srgbClr val="231F20"/>
-                </a:solidFill>
-                <a:latin typeface="Arial"/>
-                <a:cs typeface="Arial"/>
-              </a:rPr>
-              <a:t>from</a:t>
-            </a:r>
-            <a:r>
-              <a:rPr sz="2400" spc="-15" dirty="0">
-                <a:solidFill>
-                  <a:srgbClr val="231F20"/>
-                </a:solidFill>
-                <a:latin typeface="Arial"/>
-                <a:cs typeface="Arial"/>
-              </a:rPr>
-              <a:t> </a:t>
-            </a:r>
-            <a:r>
-              <a:rPr sz="2400" dirty="0">
-                <a:solidFill>
-                  <a:srgbClr val="231F20"/>
-                </a:solidFill>
-                <a:latin typeface="Arial"/>
-                <a:cs typeface="Arial"/>
-              </a:rPr>
-              <a:t>the</a:t>
-            </a:r>
-            <a:r>
-              <a:rPr sz="2400" spc="-15" dirty="0">
-                <a:solidFill>
-                  <a:srgbClr val="231F20"/>
-                </a:solidFill>
-                <a:latin typeface="Arial"/>
-                <a:cs typeface="Arial"/>
-              </a:rPr>
-              <a:t> </a:t>
-            </a:r>
-            <a:r>
-              <a:rPr sz="2400" spc="-5" dirty="0">
-                <a:solidFill>
-                  <a:srgbClr val="231F20"/>
-                </a:solidFill>
-                <a:latin typeface="Arial"/>
-                <a:cs typeface="Arial"/>
-              </a:rPr>
-              <a:t>bottom-up.</a:t>
-            </a:r>
-            <a:endParaRPr sz="2400" dirty="0">
-              <a:latin typeface="Arial"/>
-              <a:cs typeface="Arial"/>
-            </a:endParaRPr>
-          </a:p>
-        </p:txBody>
-      </p:sp>
-      <p:sp>
-        <p:nvSpPr>
-          <p:cNvPr id="4" name="object 4"/>
-          <p:cNvSpPr txBox="1">
-            <a:spLocks noGrp="1"/>
-          </p:cNvSpPr>
-          <p:nvPr>
-            <p:ph type="sldNum" sz="quarter" idx="7"/>
-          </p:nvPr>
-        </p:nvSpPr>
-        <p:spPr>
-          <a:prstGeom prst="rect">
-            <a:avLst/>
-          </a:prstGeom>
-        </p:spPr>
-        <p:txBody>
-          <a:bodyPr vert="horz" wrap="square" lIns="0" tIns="0" rIns="0" bIns="0" rtlCol="0">
-            <a:spAutoFit/>
-          </a:bodyPr>
-          <a:lstStyle/>
-          <a:p>
-            <a:pPr marL="12700">
-              <a:lnSpc>
-                <a:spcPts val="1425"/>
-              </a:lnSpc>
-            </a:pPr>
-            <a:r>
-              <a:rPr spc="-5" dirty="0"/>
-              <a:t>page</a:t>
-            </a:r>
-            <a:r>
-              <a:rPr spc="-50" dirty="0"/>
-              <a:t> </a:t>
-            </a:r>
-            <a:fld id="{81D60167-4931-47E6-BA6A-407CBD079E47}" type="slidenum">
-              <a:rPr dirty="0"/>
-              <a:t>31</a:t>
-            </a:fld>
-            <a:endParaRPr dirty="0"/>
-          </a:p>
-        </p:txBody>
-      </p:sp>
-      <p:sp>
-        <p:nvSpPr>
-          <p:cNvPr id="3" name="object 3"/>
-          <p:cNvSpPr txBox="1">
-            <a:spLocks noGrp="1"/>
-          </p:cNvSpPr>
-          <p:nvPr>
-            <p:ph type="title"/>
-          </p:nvPr>
-        </p:nvSpPr>
-        <p:spPr>
-          <a:xfrm>
-            <a:off x="972819" y="933624"/>
-            <a:ext cx="5217160" cy="574040"/>
-          </a:xfrm>
-          <a:prstGeom prst="rect">
-            <a:avLst/>
-          </a:prstGeom>
-        </p:spPr>
-        <p:txBody>
-          <a:bodyPr vert="horz" wrap="square" lIns="0" tIns="12700" rIns="0" bIns="0" rtlCol="0">
-            <a:spAutoFit/>
-          </a:bodyPr>
-          <a:lstStyle/>
-          <a:p>
-            <a:pPr marL="12700">
-              <a:lnSpc>
-                <a:spcPct val="100000"/>
-              </a:lnSpc>
-              <a:spcBef>
-                <a:spcPts val="100"/>
-              </a:spcBef>
-            </a:pPr>
-            <a:r>
-              <a:rPr spc="25" dirty="0"/>
-              <a:t>Agent-based</a:t>
-            </a:r>
-            <a:r>
-              <a:rPr spc="-25" dirty="0"/>
-              <a:t> </a:t>
-            </a:r>
-            <a:r>
-              <a:rPr spc="35" dirty="0"/>
-              <a:t>Modeling</a:t>
-            </a:r>
-          </a:p>
-        </p:txBody>
-      </p:sp>
-    </p:spTree>
-  </p:cSld>
-  <p:clrMapOvr>
-    <a:masterClrMapping/>
-  </p:clrMapOvr>
-</p:sld>
-</file>
-
-<file path=ppt/slides/slide32.xml><?xml version="1.0" encoding="utf-8"?>
-<p:sld xmlns:a="http://schemas.openxmlformats.org/drawingml/2006/main" xmlns:r="http://schemas.openxmlformats.org/officeDocument/2006/relationships" xmlns:p="http://schemas.openxmlformats.org/presentationml/2006/main">
-  <p:cSld>
-    <p:spTree>
-      <p:nvGrpSpPr>
-        <p:cNvPr id="1" name=""/>
-        <p:cNvGrpSpPr/>
-        <p:nvPr/>
-      </p:nvGrpSpPr>
-      <p:grpSpPr>
-        <a:xfrm>
-          <a:off x="0" y="0"/>
-          <a:ext cx="0" cy="0"/>
-          <a:chOff x="0" y="0"/>
-          <a:chExt cx="0" cy="0"/>
-        </a:xfrm>
-      </p:grpSpPr>
-      <p:sp>
-        <p:nvSpPr>
-          <p:cNvPr id="2" name="object 2"/>
-          <p:cNvSpPr txBox="1"/>
-          <p:nvPr/>
-        </p:nvSpPr>
-        <p:spPr>
-          <a:xfrm>
-            <a:off x="1282700" y="1821868"/>
-            <a:ext cx="6494145" cy="3683000"/>
-          </a:xfrm>
-          <a:prstGeom prst="rect">
-            <a:avLst/>
-          </a:prstGeom>
-        </p:spPr>
-        <p:txBody>
-          <a:bodyPr vert="horz" wrap="square" lIns="0" tIns="12700" rIns="0" bIns="0" rtlCol="0">
-            <a:spAutoFit/>
-          </a:bodyPr>
-          <a:lstStyle/>
-          <a:p>
-            <a:pPr marL="12700" marR="6985">
-              <a:lnSpc>
-                <a:spcPct val="100000"/>
-              </a:lnSpc>
-              <a:spcBef>
-                <a:spcPts val="100"/>
-              </a:spcBef>
-              <a:tabLst>
-                <a:tab pos="883919" algn="l"/>
-                <a:tab pos="2635250" algn="l"/>
-                <a:tab pos="4133215" algn="l"/>
-                <a:tab pos="5970270" algn="l"/>
-              </a:tabLst>
-            </a:pPr>
-            <a:r>
-              <a:rPr sz="2400" dirty="0">
-                <a:solidFill>
-                  <a:srgbClr val="231F20"/>
-                </a:solidFill>
-                <a:latin typeface="Arial"/>
-                <a:cs typeface="Arial"/>
-              </a:rPr>
-              <a:t>The	</a:t>
-            </a:r>
-            <a:r>
-              <a:rPr sz="2400" spc="-5" dirty="0">
-                <a:solidFill>
-                  <a:srgbClr val="231F20"/>
-                </a:solidFill>
-                <a:latin typeface="Arial"/>
-                <a:cs typeface="Arial"/>
-              </a:rPr>
-              <a:t>interactio</a:t>
-            </a:r>
-            <a:r>
-              <a:rPr sz="2400" dirty="0">
-                <a:solidFill>
-                  <a:srgbClr val="231F20"/>
-                </a:solidFill>
-                <a:latin typeface="Arial"/>
-                <a:cs typeface="Arial"/>
-              </a:rPr>
-              <a:t>n	</a:t>
-            </a:r>
-            <a:r>
-              <a:rPr sz="2400" spc="-5" dirty="0">
-                <a:solidFill>
-                  <a:srgbClr val="231F20"/>
-                </a:solidFill>
-                <a:latin typeface="Arial"/>
-                <a:cs typeface="Arial"/>
-              </a:rPr>
-              <a:t>betwee</a:t>
-            </a:r>
-            <a:r>
-              <a:rPr sz="2400" dirty="0">
-                <a:solidFill>
-                  <a:srgbClr val="231F20"/>
-                </a:solidFill>
-                <a:latin typeface="Arial"/>
-                <a:cs typeface="Arial"/>
-              </a:rPr>
-              <a:t>n	consumers	</a:t>
-            </a:r>
-            <a:r>
-              <a:rPr sz="2400" spc="-5" dirty="0">
-                <a:solidFill>
-                  <a:srgbClr val="231F20"/>
-                </a:solidFill>
-                <a:latin typeface="Arial"/>
-                <a:cs typeface="Arial"/>
-              </a:rPr>
-              <a:t>and  producers.</a:t>
-            </a:r>
-            <a:endParaRPr sz="2400">
-              <a:latin typeface="Arial"/>
-              <a:cs typeface="Arial"/>
-            </a:endParaRPr>
-          </a:p>
-          <a:p>
-            <a:pPr>
-              <a:lnSpc>
-                <a:spcPct val="100000"/>
-              </a:lnSpc>
-              <a:spcBef>
-                <a:spcPts val="5"/>
-              </a:spcBef>
-            </a:pPr>
-            <a:endParaRPr sz="2500">
-              <a:latin typeface="Arial"/>
-              <a:cs typeface="Arial"/>
-            </a:endParaRPr>
-          </a:p>
-          <a:p>
-            <a:pPr marL="12700" marR="278765">
-              <a:lnSpc>
-                <a:spcPct val="100000"/>
-              </a:lnSpc>
-            </a:pPr>
-            <a:r>
-              <a:rPr sz="2400" spc="-5" dirty="0">
-                <a:solidFill>
-                  <a:srgbClr val="231F20"/>
-                </a:solidFill>
-                <a:latin typeface="Arial"/>
-                <a:cs typeface="Arial"/>
-              </a:rPr>
-              <a:t>Consumer decision </a:t>
-            </a:r>
-            <a:r>
-              <a:rPr sz="2400" dirty="0">
-                <a:solidFill>
-                  <a:srgbClr val="231F20"/>
-                </a:solidFill>
-                <a:latin typeface="Arial"/>
-                <a:cs typeface="Arial"/>
-              </a:rPr>
-              <a:t>making: WTP </a:t>
-            </a:r>
-            <a:r>
-              <a:rPr sz="2400" spc="-45" dirty="0">
-                <a:solidFill>
-                  <a:srgbClr val="231F20"/>
-                </a:solidFill>
-                <a:latin typeface="Arial"/>
-                <a:cs typeface="Arial"/>
-              </a:rPr>
-              <a:t>v.s. </a:t>
-            </a:r>
-            <a:r>
-              <a:rPr sz="2400" spc="-5" dirty="0">
-                <a:solidFill>
-                  <a:srgbClr val="231F20"/>
-                </a:solidFill>
-                <a:latin typeface="Arial"/>
-                <a:cs typeface="Arial"/>
-              </a:rPr>
-              <a:t>price </a:t>
-            </a:r>
-            <a:r>
-              <a:rPr sz="2400" dirty="0">
-                <a:solidFill>
-                  <a:srgbClr val="231F20"/>
-                </a:solidFill>
-                <a:latin typeface="Arial"/>
-                <a:cs typeface="Arial"/>
-              </a:rPr>
-              <a:t> Producer</a:t>
-            </a:r>
-            <a:r>
-              <a:rPr sz="2400" spc="-15" dirty="0">
-                <a:solidFill>
-                  <a:srgbClr val="231F20"/>
-                </a:solidFill>
-                <a:latin typeface="Arial"/>
-                <a:cs typeface="Arial"/>
-              </a:rPr>
-              <a:t> </a:t>
-            </a:r>
-            <a:r>
-              <a:rPr sz="2400" spc="-5" dirty="0">
-                <a:solidFill>
-                  <a:srgbClr val="231F20"/>
-                </a:solidFill>
-                <a:latin typeface="Arial"/>
-                <a:cs typeface="Arial"/>
-              </a:rPr>
-              <a:t>decision</a:t>
-            </a:r>
-            <a:r>
-              <a:rPr sz="2400" spc="-20" dirty="0">
-                <a:solidFill>
-                  <a:srgbClr val="231F20"/>
-                </a:solidFill>
-                <a:latin typeface="Arial"/>
-                <a:cs typeface="Arial"/>
-              </a:rPr>
-              <a:t> </a:t>
-            </a:r>
-            <a:r>
-              <a:rPr sz="2400" dirty="0">
-                <a:solidFill>
-                  <a:srgbClr val="231F20"/>
-                </a:solidFill>
-                <a:latin typeface="Arial"/>
-                <a:cs typeface="Arial"/>
-              </a:rPr>
-              <a:t>making:</a:t>
-            </a:r>
-            <a:r>
-              <a:rPr sz="2400" spc="-15" dirty="0">
-                <a:solidFill>
-                  <a:srgbClr val="231F20"/>
-                </a:solidFill>
-                <a:latin typeface="Arial"/>
-                <a:cs typeface="Arial"/>
-              </a:rPr>
-              <a:t> </a:t>
-            </a:r>
-            <a:r>
-              <a:rPr sz="2400" spc="-5" dirty="0">
-                <a:solidFill>
-                  <a:srgbClr val="231F20"/>
-                </a:solidFill>
-                <a:latin typeface="Arial"/>
-                <a:cs typeface="Arial"/>
-              </a:rPr>
-              <a:t>opp.</a:t>
-            </a:r>
-            <a:r>
-              <a:rPr sz="2400" spc="-20" dirty="0">
-                <a:solidFill>
-                  <a:srgbClr val="231F20"/>
-                </a:solidFill>
-                <a:latin typeface="Arial"/>
-                <a:cs typeface="Arial"/>
-              </a:rPr>
-              <a:t> </a:t>
-            </a:r>
-            <a:r>
-              <a:rPr sz="2400" dirty="0">
-                <a:solidFill>
-                  <a:srgbClr val="231F20"/>
-                </a:solidFill>
-                <a:latin typeface="Arial"/>
-                <a:cs typeface="Arial"/>
-              </a:rPr>
-              <a:t>cost</a:t>
-            </a:r>
-            <a:r>
-              <a:rPr sz="2400" spc="-10" dirty="0">
-                <a:solidFill>
-                  <a:srgbClr val="231F20"/>
-                </a:solidFill>
-                <a:latin typeface="Arial"/>
-                <a:cs typeface="Arial"/>
-              </a:rPr>
-              <a:t> </a:t>
-            </a:r>
-            <a:r>
-              <a:rPr sz="2400" spc="-45" dirty="0">
-                <a:solidFill>
-                  <a:srgbClr val="231F20"/>
-                </a:solidFill>
-                <a:latin typeface="Arial"/>
-                <a:cs typeface="Arial"/>
-              </a:rPr>
-              <a:t>v.s.</a:t>
-            </a:r>
-            <a:r>
-              <a:rPr sz="2400" spc="-15" dirty="0">
-                <a:solidFill>
-                  <a:srgbClr val="231F20"/>
-                </a:solidFill>
-                <a:latin typeface="Arial"/>
-                <a:cs typeface="Arial"/>
-              </a:rPr>
-              <a:t> </a:t>
-            </a:r>
-            <a:r>
-              <a:rPr sz="2400" spc="-5" dirty="0">
-                <a:solidFill>
-                  <a:srgbClr val="231F20"/>
-                </a:solidFill>
-                <a:latin typeface="Arial"/>
-                <a:cs typeface="Arial"/>
-              </a:rPr>
-              <a:t>price</a:t>
-            </a:r>
-            <a:endParaRPr sz="2400">
-              <a:latin typeface="Arial"/>
-              <a:cs typeface="Arial"/>
-            </a:endParaRPr>
-          </a:p>
-          <a:p>
-            <a:pPr>
-              <a:lnSpc>
-                <a:spcPct val="100000"/>
-              </a:lnSpc>
-              <a:spcBef>
-                <a:spcPts val="5"/>
-              </a:spcBef>
-            </a:pPr>
-            <a:endParaRPr sz="2500">
-              <a:latin typeface="Arial"/>
-              <a:cs typeface="Arial"/>
-            </a:endParaRPr>
-          </a:p>
-          <a:p>
-            <a:pPr marL="12700">
-              <a:lnSpc>
-                <a:spcPct val="100000"/>
-              </a:lnSpc>
-            </a:pPr>
-            <a:r>
-              <a:rPr sz="2400" dirty="0">
-                <a:solidFill>
-                  <a:srgbClr val="231F20"/>
-                </a:solidFill>
-                <a:latin typeface="Arial"/>
-                <a:cs typeface="Arial"/>
-              </a:rPr>
-              <a:t>Interaction:</a:t>
-            </a:r>
-            <a:r>
-              <a:rPr sz="2400" spc="-25" dirty="0">
-                <a:solidFill>
-                  <a:srgbClr val="231F20"/>
-                </a:solidFill>
-                <a:latin typeface="Arial"/>
-                <a:cs typeface="Arial"/>
-              </a:rPr>
-              <a:t> </a:t>
-            </a:r>
-            <a:r>
-              <a:rPr sz="2400" dirty="0">
-                <a:solidFill>
-                  <a:srgbClr val="231F20"/>
-                </a:solidFill>
-                <a:latin typeface="Arial"/>
-                <a:cs typeface="Arial"/>
-              </a:rPr>
-              <a:t>the</a:t>
-            </a:r>
-            <a:r>
-              <a:rPr sz="2400" spc="-25" dirty="0">
-                <a:solidFill>
-                  <a:srgbClr val="231F20"/>
-                </a:solidFill>
-                <a:latin typeface="Arial"/>
-                <a:cs typeface="Arial"/>
-              </a:rPr>
-              <a:t> </a:t>
-            </a:r>
-            <a:r>
-              <a:rPr sz="2400" dirty="0">
-                <a:solidFill>
-                  <a:srgbClr val="231F20"/>
-                </a:solidFill>
-                <a:latin typeface="Arial"/>
-                <a:cs typeface="Arial"/>
-              </a:rPr>
-              <a:t>market</a:t>
-            </a:r>
-            <a:r>
-              <a:rPr sz="2400" spc="-25" dirty="0">
-                <a:solidFill>
-                  <a:srgbClr val="231F20"/>
-                </a:solidFill>
-                <a:latin typeface="Arial"/>
-                <a:cs typeface="Arial"/>
-              </a:rPr>
-              <a:t> </a:t>
-            </a:r>
-            <a:r>
-              <a:rPr sz="2400" dirty="0">
-                <a:solidFill>
-                  <a:srgbClr val="231F20"/>
-                </a:solidFill>
-                <a:latin typeface="Arial"/>
-                <a:cs typeface="Arial"/>
-              </a:rPr>
-              <a:t>mechanism</a:t>
-            </a:r>
-            <a:endParaRPr sz="2400">
-              <a:latin typeface="Arial"/>
-              <a:cs typeface="Arial"/>
-            </a:endParaRPr>
-          </a:p>
-          <a:p>
-            <a:pPr>
-              <a:lnSpc>
-                <a:spcPct val="100000"/>
-              </a:lnSpc>
-              <a:spcBef>
-                <a:spcPts val="5"/>
-              </a:spcBef>
-            </a:pPr>
-            <a:endParaRPr sz="2500">
-              <a:latin typeface="Arial"/>
-              <a:cs typeface="Arial"/>
-            </a:endParaRPr>
-          </a:p>
-          <a:p>
-            <a:pPr marL="12700" marR="5080">
-              <a:lnSpc>
-                <a:spcPct val="100000"/>
-              </a:lnSpc>
-            </a:pPr>
-            <a:r>
-              <a:rPr sz="2400" dirty="0">
-                <a:solidFill>
-                  <a:srgbClr val="231F20"/>
-                </a:solidFill>
-                <a:latin typeface="Arial"/>
-                <a:cs typeface="Arial"/>
-              </a:rPr>
-              <a:t>Outcome:</a:t>
-            </a:r>
-            <a:r>
-              <a:rPr sz="2400" spc="55" dirty="0">
-                <a:solidFill>
-                  <a:srgbClr val="231F20"/>
-                </a:solidFill>
-                <a:latin typeface="Arial"/>
-                <a:cs typeface="Arial"/>
-              </a:rPr>
-              <a:t> </a:t>
-            </a:r>
-            <a:r>
-              <a:rPr sz="2400" dirty="0">
-                <a:solidFill>
-                  <a:srgbClr val="231F20"/>
-                </a:solidFill>
-                <a:latin typeface="Arial"/>
-                <a:cs typeface="Arial"/>
-              </a:rPr>
-              <a:t>market</a:t>
-            </a:r>
-            <a:r>
-              <a:rPr sz="2400" spc="50" dirty="0">
-                <a:solidFill>
-                  <a:srgbClr val="231F20"/>
-                </a:solidFill>
-                <a:latin typeface="Arial"/>
-                <a:cs typeface="Arial"/>
-              </a:rPr>
-              <a:t> </a:t>
-            </a:r>
-            <a:r>
-              <a:rPr sz="2400" dirty="0">
-                <a:solidFill>
-                  <a:srgbClr val="231F20"/>
-                </a:solidFill>
-                <a:latin typeface="Arial"/>
-                <a:cs typeface="Arial"/>
-              </a:rPr>
-              <a:t>status</a:t>
-            </a:r>
-            <a:r>
-              <a:rPr sz="2400" spc="50" dirty="0">
-                <a:solidFill>
-                  <a:srgbClr val="231F20"/>
-                </a:solidFill>
-                <a:latin typeface="Arial"/>
-                <a:cs typeface="Arial"/>
-              </a:rPr>
-              <a:t> </a:t>
-            </a:r>
-            <a:r>
-              <a:rPr sz="2400" dirty="0">
-                <a:solidFill>
-                  <a:srgbClr val="231F20"/>
-                </a:solidFill>
-                <a:latin typeface="Arial"/>
-                <a:cs typeface="Arial"/>
-              </a:rPr>
-              <a:t>(i.e.,</a:t>
-            </a:r>
-            <a:r>
-              <a:rPr sz="2400" spc="50" dirty="0">
-                <a:solidFill>
-                  <a:srgbClr val="231F20"/>
-                </a:solidFill>
-                <a:latin typeface="Arial"/>
-                <a:cs typeface="Arial"/>
-              </a:rPr>
-              <a:t> </a:t>
-            </a:r>
-            <a:r>
-              <a:rPr sz="2400" dirty="0">
-                <a:solidFill>
-                  <a:srgbClr val="231F20"/>
-                </a:solidFill>
-                <a:latin typeface="Arial"/>
-                <a:cs typeface="Arial"/>
-              </a:rPr>
-              <a:t>shortage,</a:t>
-            </a:r>
-            <a:r>
-              <a:rPr sz="2400" spc="50" dirty="0">
-                <a:solidFill>
-                  <a:srgbClr val="231F20"/>
-                </a:solidFill>
-                <a:latin typeface="Arial"/>
-                <a:cs typeface="Arial"/>
-              </a:rPr>
-              <a:t> </a:t>
-            </a:r>
-            <a:r>
-              <a:rPr sz="2400" dirty="0">
-                <a:solidFill>
-                  <a:srgbClr val="231F20"/>
-                </a:solidFill>
-                <a:latin typeface="Arial"/>
-                <a:cs typeface="Arial"/>
-              </a:rPr>
-              <a:t>surplus, </a:t>
-            </a:r>
-            <a:r>
-              <a:rPr sz="2400" spc="-655" dirty="0">
-                <a:solidFill>
-                  <a:srgbClr val="231F20"/>
-                </a:solidFill>
-                <a:latin typeface="Arial"/>
-                <a:cs typeface="Arial"/>
-              </a:rPr>
-              <a:t> </a:t>
-            </a:r>
-            <a:r>
-              <a:rPr sz="2400" spc="-5" dirty="0">
-                <a:solidFill>
-                  <a:srgbClr val="231F20"/>
-                </a:solidFill>
-                <a:latin typeface="Arial"/>
-                <a:cs typeface="Arial"/>
-              </a:rPr>
-              <a:t>or</a:t>
-            </a:r>
-            <a:r>
-              <a:rPr sz="2400" spc="-10" dirty="0">
-                <a:solidFill>
-                  <a:srgbClr val="231F20"/>
-                </a:solidFill>
-                <a:latin typeface="Arial"/>
-                <a:cs typeface="Arial"/>
-              </a:rPr>
-              <a:t> </a:t>
-            </a:r>
-            <a:r>
-              <a:rPr sz="2400" spc="-5" dirty="0">
-                <a:solidFill>
-                  <a:srgbClr val="231F20"/>
-                </a:solidFill>
-                <a:latin typeface="Arial"/>
-                <a:cs typeface="Arial"/>
-              </a:rPr>
-              <a:t>equilibrium)</a:t>
-            </a:r>
-            <a:endParaRPr sz="2400">
-              <a:latin typeface="Arial"/>
-              <a:cs typeface="Arial"/>
-            </a:endParaRPr>
-          </a:p>
-        </p:txBody>
-      </p:sp>
-      <p:sp>
-        <p:nvSpPr>
-          <p:cNvPr id="4" name="object 4"/>
-          <p:cNvSpPr txBox="1">
-            <a:spLocks noGrp="1"/>
-          </p:cNvSpPr>
-          <p:nvPr>
-            <p:ph type="sldNum" sz="quarter" idx="7"/>
-          </p:nvPr>
-        </p:nvSpPr>
-        <p:spPr>
-          <a:prstGeom prst="rect">
-            <a:avLst/>
-          </a:prstGeom>
-        </p:spPr>
-        <p:txBody>
-          <a:bodyPr vert="horz" wrap="square" lIns="0" tIns="0" rIns="0" bIns="0" rtlCol="0">
-            <a:spAutoFit/>
-          </a:bodyPr>
-          <a:lstStyle/>
-          <a:p>
-            <a:pPr marL="12700">
-              <a:lnSpc>
-                <a:spcPts val="1425"/>
-              </a:lnSpc>
-            </a:pPr>
-            <a:r>
-              <a:rPr spc="-5" dirty="0"/>
-              <a:t>page</a:t>
-            </a:r>
-            <a:r>
-              <a:rPr spc="-50" dirty="0"/>
-              <a:t> </a:t>
-            </a:r>
-            <a:fld id="{81D60167-4931-47E6-BA6A-407CBD079E47}" type="slidenum">
-              <a:rPr dirty="0"/>
-              <a:t>32</a:t>
-            </a:fld>
-            <a:endParaRPr dirty="0"/>
-          </a:p>
-        </p:txBody>
-      </p:sp>
-      <p:sp>
-        <p:nvSpPr>
-          <p:cNvPr id="3" name="object 3"/>
-          <p:cNvSpPr txBox="1">
-            <a:spLocks noGrp="1"/>
-          </p:cNvSpPr>
-          <p:nvPr>
-            <p:ph type="title"/>
-          </p:nvPr>
-        </p:nvSpPr>
-        <p:spPr>
-          <a:xfrm>
-            <a:off x="972819" y="933624"/>
-            <a:ext cx="5217160" cy="574040"/>
-          </a:xfrm>
-          <a:prstGeom prst="rect">
-            <a:avLst/>
-          </a:prstGeom>
-        </p:spPr>
-        <p:txBody>
-          <a:bodyPr vert="horz" wrap="square" lIns="0" tIns="12700" rIns="0" bIns="0" rtlCol="0">
-            <a:spAutoFit/>
-          </a:bodyPr>
-          <a:lstStyle/>
-          <a:p>
-            <a:pPr marL="12700">
-              <a:lnSpc>
-                <a:spcPct val="100000"/>
-              </a:lnSpc>
-              <a:spcBef>
-                <a:spcPts val="100"/>
-              </a:spcBef>
-            </a:pPr>
-            <a:r>
-              <a:rPr spc="25" dirty="0"/>
-              <a:t>Agent-based</a:t>
-            </a:r>
-            <a:r>
-              <a:rPr spc="-25" dirty="0"/>
-              <a:t> </a:t>
-            </a:r>
-            <a:r>
-              <a:rPr spc="35" dirty="0"/>
-              <a:t>Modeling</a:t>
-            </a:r>
-          </a:p>
-        </p:txBody>
-      </p:sp>
-    </p:spTree>
-  </p:cSld>
-  <p:clrMapOvr>
-    <a:masterClrMapping/>
-  </p:clrMapOvr>
-</p:sld>
-</file>
-
-<file path=ppt/slides/slide33.xml><?xml version="1.0" encoding="utf-8"?>
-<p:sld xmlns:a="http://schemas.openxmlformats.org/drawingml/2006/main" xmlns:r="http://schemas.openxmlformats.org/officeDocument/2006/relationships" xmlns:p="http://schemas.openxmlformats.org/presentationml/2006/main">
-  <p:cSld>
-    <p:spTree>
-      <p:nvGrpSpPr>
-        <p:cNvPr id="1" name=""/>
-        <p:cNvGrpSpPr/>
-        <p:nvPr/>
-      </p:nvGrpSpPr>
-      <p:grpSpPr>
-        <a:xfrm>
-          <a:off x="0" y="0"/>
-          <a:ext cx="0" cy="0"/>
-          <a:chOff x="0" y="0"/>
-          <a:chExt cx="0" cy="0"/>
-        </a:xfrm>
-      </p:grpSpPr>
-      <p:sp>
-        <p:nvSpPr>
-          <p:cNvPr id="2" name="object 2"/>
-          <p:cNvSpPr txBox="1"/>
-          <p:nvPr/>
-        </p:nvSpPr>
-        <p:spPr>
-          <a:xfrm>
             <a:off x="1600200" y="2362200"/>
             <a:ext cx="6494145" cy="2675091"/>
           </a:xfrm>
@@ -20976,7 +19453,7 @@
             </a:r>
             <a:fld id="{81D60167-4931-47E6-BA6A-407CBD079E47}" type="slidenum">
               <a:rPr dirty="0"/>
-              <a:t>33</a:t>
+              <a:t>31</a:t>
             </a:fld>
             <a:endParaRPr dirty="0"/>
           </a:p>
@@ -21036,7 +19513,7 @@
 </p:sld>
 </file>
 
-<file path=ppt/slides/slide34.xml><?xml version="1.0" encoding="utf-8"?>
+<file path=ppt/slides/slide32.xml><?xml version="1.0" encoding="utf-8"?>
 <p:sld xmlns:a="http://schemas.openxmlformats.org/drawingml/2006/main" xmlns:r="http://schemas.openxmlformats.org/officeDocument/2006/relationships" xmlns:p="http://schemas.openxmlformats.org/presentationml/2006/main">
   <p:cSld>
     <p:spTree>
@@ -21231,7 +19708,7 @@
             </a:r>
             <a:fld id="{81D60167-4931-47E6-BA6A-407CBD079E47}" type="slidenum">
               <a:rPr dirty="0"/>
-              <a:t>34</a:t>
+              <a:t>32</a:t>
             </a:fld>
             <a:endParaRPr dirty="0"/>
           </a:p>
@@ -21297,7 +19774,7 @@
 </p:sld>
 </file>
 
-<file path=ppt/slides/slide35.xml><?xml version="1.0" encoding="utf-8"?>
+<file path=ppt/slides/slide33.xml><?xml version="1.0" encoding="utf-8"?>
 <p:sld xmlns:a="http://schemas.openxmlformats.org/drawingml/2006/main" xmlns:r="http://schemas.openxmlformats.org/officeDocument/2006/relationships" xmlns:p="http://schemas.openxmlformats.org/presentationml/2006/main">
   <p:cSld>
     <p:spTree>
@@ -21502,7 +19979,7 @@
             </a:r>
             <a:fld id="{81D60167-4931-47E6-BA6A-407CBD079E47}" type="slidenum">
               <a:rPr dirty="0"/>
-              <a:t>35</a:t>
+              <a:t>33</a:t>
             </a:fld>
             <a:endParaRPr dirty="0"/>
           </a:p>
@@ -21568,7 +20045,7 @@
 </p:sld>
 </file>
 
-<file path=ppt/slides/slide36.xml><?xml version="1.0" encoding="utf-8"?>
+<file path=ppt/slides/slide34.xml><?xml version="1.0" encoding="utf-8"?>
 <p:sld xmlns:a="http://schemas.openxmlformats.org/drawingml/2006/main" xmlns:r="http://schemas.openxmlformats.org/officeDocument/2006/relationships" xmlns:p="http://schemas.openxmlformats.org/presentationml/2006/main">
   <p:cSld>
     <p:spTree>
@@ -21690,7 +20167,7 @@
             </a:r>
             <a:fld id="{81D60167-4931-47E6-BA6A-407CBD079E47}" type="slidenum">
               <a:rPr dirty="0"/>
-              <a:t>36</a:t>
+              <a:t>34</a:t>
             </a:fld>
             <a:endParaRPr dirty="0"/>
           </a:p>
@@ -21756,7 +20233,7 @@
 </p:sld>
 </file>
 
-<file path=ppt/slides/slide37.xml><?xml version="1.0" encoding="utf-8"?>
+<file path=ppt/slides/slide35.xml><?xml version="1.0" encoding="utf-8"?>
 <p:sld xmlns:a="http://schemas.openxmlformats.org/drawingml/2006/main" xmlns:r="http://schemas.openxmlformats.org/officeDocument/2006/relationships" xmlns:p="http://schemas.openxmlformats.org/presentationml/2006/main">
   <p:cSld>
     <p:spTree>
@@ -21878,7 +20355,7 @@
             </a:r>
             <a:fld id="{81D60167-4931-47E6-BA6A-407CBD079E47}" type="slidenum">
               <a:rPr dirty="0"/>
-              <a:t>37</a:t>
+              <a:t>35</a:t>
             </a:fld>
             <a:endParaRPr dirty="0"/>
           </a:p>
@@ -21935,6 +20412,1033 @@
     <p:extLst>
       <p:ext uri="{BB962C8B-B14F-4D97-AF65-F5344CB8AC3E}">
         <p14:creationId xmlns:p14="http://schemas.microsoft.com/office/powerpoint/2010/main" val="2196472191"/>
+      </p:ext>
+    </p:extLst>
+  </p:cSld>
+  <p:clrMapOvr>
+    <a:masterClrMapping/>
+  </p:clrMapOvr>
+</p:sld>
+</file>
+
+<file path=ppt/slides/slide36.xml><?xml version="1.0" encoding="utf-8"?>
+<p:sld xmlns:a="http://schemas.openxmlformats.org/drawingml/2006/main" xmlns:r="http://schemas.openxmlformats.org/officeDocument/2006/relationships" xmlns:p="http://schemas.openxmlformats.org/presentationml/2006/main">
+  <p:cSld>
+    <p:spTree>
+      <p:nvGrpSpPr>
+        <p:cNvPr id="1" name=""/>
+        <p:cNvGrpSpPr/>
+        <p:nvPr/>
+      </p:nvGrpSpPr>
+      <p:grpSpPr>
+        <a:xfrm>
+          <a:off x="0" y="0"/>
+          <a:ext cx="0" cy="0"/>
+          <a:chOff x="0" y="0"/>
+          <a:chExt cx="0" cy="0"/>
+        </a:xfrm>
+      </p:grpSpPr>
+      <p:sp>
+        <p:nvSpPr>
+          <p:cNvPr id="2" name="Title 1">
+            <a:extLst>
+              <a:ext uri="{FF2B5EF4-FFF2-40B4-BE49-F238E27FC236}">
+                <a16:creationId xmlns:a16="http://schemas.microsoft.com/office/drawing/2014/main" id="{CC0C084E-0F75-6BFB-2842-9EE57130CE36}"/>
+              </a:ext>
+            </a:extLst>
+          </p:cNvPr>
+          <p:cNvSpPr>
+            <a:spLocks noGrp="1"/>
+          </p:cNvSpPr>
+          <p:nvPr>
+            <p:ph type="title"/>
+          </p:nvPr>
+        </p:nvSpPr>
+        <p:spPr>
+          <a:xfrm>
+            <a:off x="990600" y="914400"/>
+            <a:ext cx="7806689" cy="574040"/>
+          </a:xfrm>
+        </p:spPr>
+        <p:txBody>
+          <a:bodyPr/>
+          <a:lstStyle/>
+          <a:p>
+            <a:r>
+              <a:rPr lang="en-US" dirty="0"/>
+              <a:t>Project</a:t>
+            </a:r>
+          </a:p>
+        </p:txBody>
+      </p:sp>
+      <p:sp>
+        <p:nvSpPr>
+          <p:cNvPr id="3" name="Text Placeholder 2">
+            <a:extLst>
+              <a:ext uri="{FF2B5EF4-FFF2-40B4-BE49-F238E27FC236}">
+                <a16:creationId xmlns:a16="http://schemas.microsoft.com/office/drawing/2014/main" id="{A723667F-DC69-554E-329F-38B4F426F9DA}"/>
+              </a:ext>
+            </a:extLst>
+          </p:cNvPr>
+          <p:cNvSpPr>
+            <a:spLocks noGrp="1"/>
+          </p:cNvSpPr>
+          <p:nvPr>
+            <p:ph type="body" idx="1"/>
+          </p:nvPr>
+        </p:nvSpPr>
+        <p:spPr>
+          <a:xfrm>
+            <a:off x="990601" y="1730428"/>
+            <a:ext cx="7086600" cy="4062651"/>
+          </a:xfrm>
+        </p:spPr>
+        <p:txBody>
+          <a:bodyPr/>
+          <a:lstStyle/>
+          <a:p>
+            <a:r>
+              <a:rPr lang="en-US" dirty="0"/>
+              <a:t>In this project, you will apply object-oriented programing technique to simulate the market demand/supply model.</a:t>
+            </a:r>
+          </a:p>
+          <a:p>
+            <a:endParaRPr lang="en-US" dirty="0"/>
+          </a:p>
+          <a:p>
+            <a:pPr marL="342900" indent="-342900">
+              <a:buClr>
+                <a:srgbClr val="0070C0"/>
+              </a:buClr>
+              <a:buFont typeface="Arial" panose="020B0604020202020204" pitchFamily="34" charset="0"/>
+              <a:buChar char="•"/>
+            </a:pPr>
+            <a:r>
+              <a:rPr lang="en-US" dirty="0"/>
+              <a:t>Define “agent” as an abstract concept</a:t>
+            </a:r>
+          </a:p>
+          <a:p>
+            <a:pPr marL="342900" indent="-342900">
+              <a:buClr>
+                <a:srgbClr val="0070C0"/>
+              </a:buClr>
+              <a:buFont typeface="Arial" panose="020B0604020202020204" pitchFamily="34" charset="0"/>
+              <a:buChar char="•"/>
+            </a:pPr>
+            <a:endParaRPr lang="en-US" dirty="0"/>
+          </a:p>
+          <a:p>
+            <a:pPr marL="342900" indent="-342900">
+              <a:buClr>
+                <a:srgbClr val="0070C0"/>
+              </a:buClr>
+              <a:buFont typeface="Arial" panose="020B0604020202020204" pitchFamily="34" charset="0"/>
+              <a:buChar char="•"/>
+            </a:pPr>
+            <a:r>
+              <a:rPr lang="en-US" dirty="0"/>
+              <a:t>Create child classes under the “agent”</a:t>
+            </a:r>
+          </a:p>
+          <a:p>
+            <a:pPr marL="342900" indent="-342900">
+              <a:buClr>
+                <a:srgbClr val="0070C0"/>
+              </a:buClr>
+              <a:buFont typeface="Arial" panose="020B0604020202020204" pitchFamily="34" charset="0"/>
+              <a:buChar char="•"/>
+            </a:pPr>
+            <a:endParaRPr lang="en-US" dirty="0"/>
+          </a:p>
+          <a:p>
+            <a:pPr marL="342900" indent="-342900">
+              <a:buClr>
+                <a:srgbClr val="0070C0"/>
+              </a:buClr>
+              <a:buFont typeface="Arial" panose="020B0604020202020204" pitchFamily="34" charset="0"/>
+              <a:buChar char="•"/>
+            </a:pPr>
+            <a:r>
+              <a:rPr lang="en-US" dirty="0"/>
+              <a:t>Instantiate “consumer” and “producer” as objects and have them interact on a simulated “market”</a:t>
+            </a:r>
+          </a:p>
+          <a:p>
+            <a:pPr marL="342900" indent="-342900">
+              <a:buClr>
+                <a:srgbClr val="0070C0"/>
+              </a:buClr>
+              <a:buFont typeface="Arial" panose="020B0604020202020204" pitchFamily="34" charset="0"/>
+              <a:buChar char="•"/>
+            </a:pPr>
+            <a:endParaRPr lang="en-US" dirty="0"/>
+          </a:p>
+          <a:p>
+            <a:pPr marL="342900" indent="-342900">
+              <a:buClr>
+                <a:srgbClr val="0070C0"/>
+              </a:buClr>
+              <a:buFont typeface="Arial" panose="020B0604020202020204" pitchFamily="34" charset="0"/>
+              <a:buChar char="•"/>
+            </a:pPr>
+            <a:r>
+              <a:rPr lang="en-US" dirty="0"/>
+              <a:t>Simulate the process of finding market equilibrium</a:t>
+            </a:r>
+          </a:p>
+        </p:txBody>
+      </p:sp>
+    </p:spTree>
+    <p:extLst>
+      <p:ext uri="{BB962C8B-B14F-4D97-AF65-F5344CB8AC3E}">
+        <p14:creationId xmlns:p14="http://schemas.microsoft.com/office/powerpoint/2010/main" val="1691547658"/>
+      </p:ext>
+    </p:extLst>
+  </p:cSld>
+  <p:clrMapOvr>
+    <a:masterClrMapping/>
+  </p:clrMapOvr>
+</p:sld>
+</file>
+
+<file path=ppt/slides/slide37.xml><?xml version="1.0" encoding="utf-8"?>
+<p:sld xmlns:a="http://schemas.openxmlformats.org/drawingml/2006/main" xmlns:r="http://schemas.openxmlformats.org/officeDocument/2006/relationships" xmlns:p="http://schemas.openxmlformats.org/presentationml/2006/main">
+  <p:cSld>
+    <p:spTree>
+      <p:nvGrpSpPr>
+        <p:cNvPr id="1" name=""/>
+        <p:cNvGrpSpPr/>
+        <p:nvPr/>
+      </p:nvGrpSpPr>
+      <p:grpSpPr>
+        <a:xfrm>
+          <a:off x="0" y="0"/>
+          <a:ext cx="0" cy="0"/>
+          <a:chOff x="0" y="0"/>
+          <a:chExt cx="0" cy="0"/>
+        </a:xfrm>
+      </p:grpSpPr>
+      <p:sp>
+        <p:nvSpPr>
+          <p:cNvPr id="2" name="object 2"/>
+          <p:cNvSpPr txBox="1"/>
+          <p:nvPr/>
+        </p:nvSpPr>
+        <p:spPr>
+          <a:xfrm>
+            <a:off x="1282700" y="1821868"/>
+            <a:ext cx="6946900" cy="2998257"/>
+          </a:xfrm>
+          <a:prstGeom prst="rect">
+            <a:avLst/>
+          </a:prstGeom>
+        </p:spPr>
+        <p:txBody>
+          <a:bodyPr vert="horz" wrap="square" lIns="0" tIns="12700" rIns="0" bIns="0" rtlCol="0">
+            <a:spAutoFit/>
+          </a:bodyPr>
+          <a:lstStyle/>
+          <a:p>
+            <a:pPr marL="12700" algn="just">
+              <a:lnSpc>
+                <a:spcPct val="100000"/>
+              </a:lnSpc>
+              <a:spcBef>
+                <a:spcPts val="100"/>
+              </a:spcBef>
+            </a:pPr>
+            <a:r>
+              <a:rPr sz="2400" dirty="0">
+                <a:solidFill>
+                  <a:srgbClr val="231F20"/>
+                </a:solidFill>
+                <a:latin typeface="Arial"/>
+                <a:cs typeface="Arial"/>
+              </a:rPr>
+              <a:t>Application</a:t>
+            </a:r>
+            <a:r>
+              <a:rPr sz="2400" spc="-20" dirty="0">
+                <a:solidFill>
+                  <a:srgbClr val="231F20"/>
+                </a:solidFill>
+                <a:latin typeface="Arial"/>
+                <a:cs typeface="Arial"/>
+              </a:rPr>
+              <a:t> </a:t>
+            </a:r>
+            <a:r>
+              <a:rPr sz="2400" spc="-5" dirty="0">
+                <a:solidFill>
+                  <a:srgbClr val="231F20"/>
+                </a:solidFill>
+                <a:latin typeface="Arial"/>
+                <a:cs typeface="Arial"/>
+              </a:rPr>
+              <a:t>of</a:t>
+            </a:r>
+            <a:r>
+              <a:rPr sz="2400" spc="-20" dirty="0">
+                <a:solidFill>
+                  <a:srgbClr val="231F20"/>
+                </a:solidFill>
+                <a:latin typeface="Arial"/>
+                <a:cs typeface="Arial"/>
+              </a:rPr>
+              <a:t> </a:t>
+            </a:r>
+            <a:r>
+              <a:rPr sz="2400" dirty="0">
+                <a:solidFill>
+                  <a:srgbClr val="231F20"/>
+                </a:solidFill>
+                <a:latin typeface="Arial"/>
+                <a:cs typeface="Arial"/>
+              </a:rPr>
+              <a:t>OOP</a:t>
+            </a:r>
+            <a:r>
+              <a:rPr sz="2400" spc="-65" dirty="0">
+                <a:solidFill>
+                  <a:srgbClr val="231F20"/>
+                </a:solidFill>
+                <a:latin typeface="Arial"/>
+                <a:cs typeface="Arial"/>
+              </a:rPr>
+              <a:t> </a:t>
+            </a:r>
+            <a:r>
+              <a:rPr sz="2400" spc="-5" dirty="0">
+                <a:solidFill>
+                  <a:srgbClr val="231F20"/>
+                </a:solidFill>
+                <a:latin typeface="Arial"/>
+                <a:cs typeface="Arial"/>
+              </a:rPr>
+              <a:t>in</a:t>
+            </a:r>
+            <a:r>
+              <a:rPr sz="2400" spc="-20" dirty="0">
+                <a:solidFill>
+                  <a:srgbClr val="231F20"/>
+                </a:solidFill>
+                <a:latin typeface="Arial"/>
+                <a:cs typeface="Arial"/>
+              </a:rPr>
+              <a:t> </a:t>
+            </a:r>
+            <a:r>
+              <a:rPr sz="2400" spc="-5" dirty="0">
+                <a:solidFill>
+                  <a:srgbClr val="231F20"/>
+                </a:solidFill>
+                <a:latin typeface="Arial"/>
+                <a:cs typeface="Arial"/>
+              </a:rPr>
+              <a:t>economics:</a:t>
+            </a:r>
+            <a:endParaRPr sz="2400" dirty="0">
+              <a:latin typeface="Arial"/>
+              <a:cs typeface="Arial"/>
+            </a:endParaRPr>
+          </a:p>
+          <a:p>
+            <a:pPr>
+              <a:lnSpc>
+                <a:spcPct val="100000"/>
+              </a:lnSpc>
+              <a:spcBef>
+                <a:spcPts val="5"/>
+              </a:spcBef>
+            </a:pPr>
+            <a:endParaRPr sz="2500" dirty="0">
+              <a:latin typeface="Arial"/>
+              <a:cs typeface="Arial"/>
+            </a:endParaRPr>
+          </a:p>
+          <a:p>
+            <a:pPr marL="12700" marR="5080" algn="just">
+              <a:lnSpc>
+                <a:spcPct val="100000"/>
+              </a:lnSpc>
+            </a:pPr>
+            <a:r>
+              <a:rPr sz="2400" dirty="0">
+                <a:solidFill>
+                  <a:srgbClr val="231F20"/>
+                </a:solidFill>
+                <a:latin typeface="Arial"/>
+                <a:cs typeface="Arial"/>
+              </a:rPr>
+              <a:t>Agent-based</a:t>
+            </a:r>
+            <a:r>
+              <a:rPr sz="2400" spc="5" dirty="0">
+                <a:solidFill>
+                  <a:srgbClr val="231F20"/>
+                </a:solidFill>
+                <a:latin typeface="Arial"/>
+                <a:cs typeface="Arial"/>
+              </a:rPr>
+              <a:t> </a:t>
+            </a:r>
+            <a:r>
+              <a:rPr sz="2400" dirty="0">
+                <a:solidFill>
+                  <a:srgbClr val="231F20"/>
+                </a:solidFill>
+                <a:latin typeface="Arial"/>
+                <a:cs typeface="Arial"/>
+              </a:rPr>
+              <a:t>modeling</a:t>
+            </a:r>
+            <a:r>
+              <a:rPr sz="2400" spc="5" dirty="0">
+                <a:solidFill>
+                  <a:srgbClr val="231F20"/>
+                </a:solidFill>
+                <a:latin typeface="Arial"/>
+                <a:cs typeface="Arial"/>
+              </a:rPr>
+              <a:t> </a:t>
+            </a:r>
+            <a:r>
+              <a:rPr sz="2400" dirty="0">
+                <a:solidFill>
+                  <a:srgbClr val="231F20"/>
+                </a:solidFill>
+                <a:latin typeface="Arial"/>
+                <a:cs typeface="Arial"/>
+              </a:rPr>
+              <a:t>(ABM)</a:t>
+            </a:r>
+            <a:r>
+              <a:rPr sz="2400" spc="5" dirty="0">
+                <a:solidFill>
+                  <a:srgbClr val="231F20"/>
+                </a:solidFill>
+                <a:latin typeface="Arial"/>
+                <a:cs typeface="Arial"/>
+              </a:rPr>
+              <a:t> </a:t>
+            </a:r>
+            <a:r>
+              <a:rPr sz="2400" spc="-5" dirty="0">
+                <a:solidFill>
+                  <a:srgbClr val="231F20"/>
+                </a:solidFill>
+                <a:latin typeface="Arial"/>
+                <a:cs typeface="Arial"/>
+              </a:rPr>
+              <a:t>is</a:t>
+            </a:r>
+            <a:r>
+              <a:rPr sz="2400" dirty="0">
+                <a:solidFill>
+                  <a:srgbClr val="231F20"/>
+                </a:solidFill>
+                <a:latin typeface="Arial"/>
+                <a:cs typeface="Arial"/>
+              </a:rPr>
+              <a:t> the</a:t>
+            </a:r>
+            <a:r>
+              <a:rPr sz="2400" spc="5" dirty="0">
+                <a:solidFill>
+                  <a:srgbClr val="231F20"/>
+                </a:solidFill>
+                <a:latin typeface="Arial"/>
+                <a:cs typeface="Arial"/>
+              </a:rPr>
+              <a:t> </a:t>
+            </a:r>
+            <a:r>
+              <a:rPr sz="2400" spc="-5" dirty="0">
+                <a:solidFill>
+                  <a:srgbClr val="231F20"/>
+                </a:solidFill>
+                <a:latin typeface="Arial"/>
+                <a:cs typeface="Arial"/>
+              </a:rPr>
+              <a:t>area</a:t>
+            </a:r>
+            <a:r>
+              <a:rPr sz="2400" dirty="0">
+                <a:solidFill>
+                  <a:srgbClr val="231F20"/>
+                </a:solidFill>
+                <a:latin typeface="Arial"/>
+                <a:cs typeface="Arial"/>
+              </a:rPr>
+              <a:t> </a:t>
+            </a:r>
+            <a:r>
+              <a:rPr sz="2400" spc="-5" dirty="0">
+                <a:solidFill>
+                  <a:srgbClr val="231F20"/>
+                </a:solidFill>
+                <a:latin typeface="Arial"/>
+                <a:cs typeface="Arial"/>
+              </a:rPr>
+              <a:t>of </a:t>
+            </a:r>
+            <a:r>
+              <a:rPr sz="2400" dirty="0">
+                <a:solidFill>
+                  <a:srgbClr val="231F20"/>
+                </a:solidFill>
+                <a:latin typeface="Arial"/>
+                <a:cs typeface="Arial"/>
+              </a:rPr>
+              <a:t> computational</a:t>
+            </a:r>
+            <a:r>
+              <a:rPr sz="2400" spc="5" dirty="0">
+                <a:solidFill>
+                  <a:srgbClr val="231F20"/>
+                </a:solidFill>
+                <a:latin typeface="Arial"/>
+                <a:cs typeface="Arial"/>
+              </a:rPr>
+              <a:t> </a:t>
+            </a:r>
+            <a:r>
+              <a:rPr sz="2400" spc="-5" dirty="0">
+                <a:solidFill>
+                  <a:srgbClr val="231F20"/>
+                </a:solidFill>
+                <a:latin typeface="Arial"/>
+                <a:cs typeface="Arial"/>
+              </a:rPr>
+              <a:t>economics</a:t>
+            </a:r>
+            <a:r>
+              <a:rPr sz="2400" dirty="0">
+                <a:solidFill>
+                  <a:srgbClr val="231F20"/>
+                </a:solidFill>
+                <a:latin typeface="Arial"/>
+                <a:cs typeface="Arial"/>
+              </a:rPr>
+              <a:t> that</a:t>
+            </a:r>
+            <a:r>
+              <a:rPr sz="2400" spc="5" dirty="0">
+                <a:solidFill>
+                  <a:srgbClr val="231F20"/>
+                </a:solidFill>
+                <a:latin typeface="Arial"/>
+                <a:cs typeface="Arial"/>
+              </a:rPr>
+              <a:t> </a:t>
+            </a:r>
+            <a:r>
+              <a:rPr sz="2400" dirty="0">
+                <a:solidFill>
+                  <a:srgbClr val="231F20"/>
+                </a:solidFill>
+                <a:latin typeface="Arial"/>
+                <a:cs typeface="Arial"/>
+              </a:rPr>
+              <a:t>studies</a:t>
+            </a:r>
+            <a:r>
+              <a:rPr sz="2400" spc="5" dirty="0">
+                <a:solidFill>
+                  <a:srgbClr val="231F20"/>
+                </a:solidFill>
+                <a:latin typeface="Arial"/>
+                <a:cs typeface="Arial"/>
+              </a:rPr>
+              <a:t> </a:t>
+            </a:r>
+            <a:r>
+              <a:rPr sz="2400" dirty="0">
+                <a:solidFill>
+                  <a:srgbClr val="231F20"/>
+                </a:solidFill>
+                <a:latin typeface="Arial"/>
+                <a:cs typeface="Arial"/>
+              </a:rPr>
+              <a:t>the </a:t>
+            </a:r>
+            <a:r>
+              <a:rPr sz="2400" spc="5" dirty="0">
+                <a:solidFill>
+                  <a:srgbClr val="231F20"/>
+                </a:solidFill>
+                <a:latin typeface="Arial"/>
+                <a:cs typeface="Arial"/>
+              </a:rPr>
+              <a:t> </a:t>
+            </a:r>
+            <a:r>
+              <a:rPr sz="2400" spc="-5" dirty="0">
+                <a:solidFill>
+                  <a:srgbClr val="231F20"/>
+                </a:solidFill>
+                <a:latin typeface="Arial"/>
+                <a:cs typeface="Arial"/>
+              </a:rPr>
+              <a:t>economi</a:t>
+            </a:r>
+            <a:r>
+              <a:rPr sz="2400" dirty="0">
+                <a:solidFill>
+                  <a:srgbClr val="231F20"/>
+                </a:solidFill>
+                <a:latin typeface="Arial"/>
+                <a:cs typeface="Arial"/>
+              </a:rPr>
+              <a:t>c</a:t>
+            </a:r>
+            <a:r>
+              <a:rPr sz="2400" spc="-409" dirty="0">
+                <a:solidFill>
+                  <a:srgbClr val="231F20"/>
+                </a:solidFill>
+                <a:latin typeface="Arial"/>
+                <a:cs typeface="Arial"/>
+              </a:rPr>
+              <a:t> </a:t>
+            </a:r>
+            <a:r>
+              <a:rPr sz="2400" spc="-5" dirty="0">
+                <a:solidFill>
+                  <a:srgbClr val="231F20"/>
+                </a:solidFill>
+                <a:latin typeface="Arial"/>
+                <a:cs typeface="Arial"/>
+              </a:rPr>
+              <a:t>processes</a:t>
+            </a:r>
+            <a:r>
+              <a:rPr sz="2400" dirty="0">
+                <a:solidFill>
+                  <a:srgbClr val="231F20"/>
+                </a:solidFill>
+                <a:latin typeface="Arial"/>
+                <a:cs typeface="Arial"/>
+              </a:rPr>
+              <a:t>,</a:t>
+            </a:r>
+            <a:r>
+              <a:rPr sz="2400" spc="-409" dirty="0">
+                <a:solidFill>
+                  <a:srgbClr val="231F20"/>
+                </a:solidFill>
+                <a:latin typeface="Arial"/>
+                <a:cs typeface="Arial"/>
+              </a:rPr>
+              <a:t> </a:t>
+            </a:r>
+            <a:r>
+              <a:rPr sz="2400" spc="-5" dirty="0">
+                <a:solidFill>
+                  <a:srgbClr val="231F20"/>
+                </a:solidFill>
+                <a:latin typeface="Arial"/>
+                <a:cs typeface="Arial"/>
+              </a:rPr>
+              <a:t>includin</a:t>
+            </a:r>
+            <a:r>
+              <a:rPr sz="2400" dirty="0">
+                <a:solidFill>
+                  <a:srgbClr val="231F20"/>
+                </a:solidFill>
+                <a:latin typeface="Arial"/>
+                <a:cs typeface="Arial"/>
+              </a:rPr>
+              <a:t>g</a:t>
+            </a:r>
+            <a:r>
+              <a:rPr sz="2400" spc="-409" dirty="0">
+                <a:solidFill>
+                  <a:srgbClr val="231F20"/>
+                </a:solidFill>
+                <a:latin typeface="Arial"/>
+                <a:cs typeface="Arial"/>
+              </a:rPr>
+              <a:t> </a:t>
+            </a:r>
+            <a:r>
+              <a:rPr sz="2400" spc="-5" dirty="0">
+                <a:solidFill>
+                  <a:srgbClr val="231F20"/>
+                </a:solidFill>
+                <a:latin typeface="Arial"/>
+                <a:cs typeface="Arial"/>
+              </a:rPr>
+              <a:t>whol</a:t>
+            </a:r>
+            <a:r>
+              <a:rPr sz="2400" dirty="0">
+                <a:solidFill>
+                  <a:srgbClr val="231F20"/>
+                </a:solidFill>
+                <a:latin typeface="Arial"/>
+                <a:cs typeface="Arial"/>
+              </a:rPr>
+              <a:t>e</a:t>
+            </a:r>
+            <a:r>
+              <a:rPr sz="2400" spc="-409" dirty="0">
+                <a:solidFill>
+                  <a:srgbClr val="231F20"/>
+                </a:solidFill>
+                <a:latin typeface="Arial"/>
+                <a:cs typeface="Arial"/>
+              </a:rPr>
+              <a:t> </a:t>
+            </a:r>
+            <a:r>
+              <a:rPr sz="2400" spc="-5" dirty="0">
+                <a:solidFill>
+                  <a:srgbClr val="231F20"/>
+                </a:solidFill>
+                <a:latin typeface="Arial"/>
+                <a:cs typeface="Arial"/>
+              </a:rPr>
+              <a:t>economies,  as</a:t>
+            </a:r>
+            <a:r>
+              <a:rPr sz="2400" spc="-10" dirty="0">
+                <a:solidFill>
+                  <a:srgbClr val="231F20"/>
+                </a:solidFill>
+                <a:latin typeface="Arial"/>
+                <a:cs typeface="Arial"/>
+              </a:rPr>
+              <a:t> </a:t>
+            </a:r>
+            <a:r>
+              <a:rPr sz="2400" spc="-5" dirty="0">
+                <a:solidFill>
+                  <a:srgbClr val="231F20"/>
+                </a:solidFill>
+                <a:latin typeface="Arial"/>
+                <a:cs typeface="Arial"/>
+              </a:rPr>
+              <a:t>dynamic</a:t>
+            </a:r>
+            <a:r>
+              <a:rPr sz="2400" spc="-10" dirty="0">
+                <a:solidFill>
+                  <a:srgbClr val="231F20"/>
+                </a:solidFill>
+                <a:latin typeface="Arial"/>
+                <a:cs typeface="Arial"/>
+              </a:rPr>
+              <a:t> </a:t>
+            </a:r>
+            <a:r>
+              <a:rPr sz="2400" dirty="0">
+                <a:solidFill>
+                  <a:srgbClr val="231F20"/>
+                </a:solidFill>
+                <a:latin typeface="Arial"/>
+                <a:cs typeface="Arial"/>
+              </a:rPr>
+              <a:t>system</a:t>
+            </a:r>
+            <a:r>
+              <a:rPr sz="2400" spc="-5" dirty="0">
+                <a:solidFill>
+                  <a:srgbClr val="231F20"/>
+                </a:solidFill>
+                <a:latin typeface="Arial"/>
+                <a:cs typeface="Arial"/>
+              </a:rPr>
+              <a:t> of</a:t>
+            </a:r>
+            <a:r>
+              <a:rPr sz="2400" spc="-10" dirty="0">
+                <a:solidFill>
+                  <a:srgbClr val="231F20"/>
+                </a:solidFill>
+                <a:latin typeface="Arial"/>
+                <a:cs typeface="Arial"/>
+              </a:rPr>
+              <a:t> </a:t>
+            </a:r>
+            <a:r>
+              <a:rPr sz="2400" spc="-5" dirty="0">
+                <a:solidFill>
+                  <a:srgbClr val="231F20"/>
+                </a:solidFill>
+                <a:latin typeface="Arial"/>
+                <a:cs typeface="Arial"/>
+              </a:rPr>
+              <a:t>interacting</a:t>
+            </a:r>
+            <a:r>
+              <a:rPr sz="2400" spc="-10" dirty="0">
+                <a:solidFill>
+                  <a:srgbClr val="231F20"/>
+                </a:solidFill>
+                <a:latin typeface="Arial"/>
+                <a:cs typeface="Arial"/>
+              </a:rPr>
+              <a:t> </a:t>
+            </a:r>
+            <a:r>
+              <a:rPr sz="2400" spc="-5" dirty="0">
+                <a:solidFill>
+                  <a:srgbClr val="231F20"/>
+                </a:solidFill>
+                <a:latin typeface="Arial"/>
+                <a:cs typeface="Arial"/>
+              </a:rPr>
+              <a:t>agents.</a:t>
+            </a:r>
+            <a:endParaRPr sz="2400" dirty="0">
+              <a:latin typeface="Arial"/>
+              <a:cs typeface="Arial"/>
+            </a:endParaRPr>
+          </a:p>
+          <a:p>
+            <a:pPr>
+              <a:lnSpc>
+                <a:spcPct val="100000"/>
+              </a:lnSpc>
+              <a:spcBef>
+                <a:spcPts val="5"/>
+              </a:spcBef>
+            </a:pPr>
+            <a:endParaRPr sz="2500" dirty="0">
+              <a:latin typeface="Arial"/>
+              <a:cs typeface="Arial"/>
+            </a:endParaRPr>
+          </a:p>
+          <a:p>
+            <a:pPr marL="12700" algn="just">
+              <a:lnSpc>
+                <a:spcPct val="100000"/>
+              </a:lnSpc>
+            </a:pPr>
+            <a:r>
+              <a:rPr lang="en-US" sz="2400" spc="-5" dirty="0">
+                <a:solidFill>
+                  <a:srgbClr val="231F20"/>
+                </a:solidFill>
+                <a:latin typeface="Arial"/>
+                <a:cs typeface="Arial"/>
+              </a:rPr>
+              <a:t>----</a:t>
+            </a:r>
+            <a:r>
+              <a:rPr sz="2400" spc="-5" dirty="0">
+                <a:solidFill>
+                  <a:srgbClr val="231F20"/>
+                </a:solidFill>
+                <a:latin typeface="Arial"/>
+                <a:cs typeface="Arial"/>
+              </a:rPr>
+              <a:t>Understand</a:t>
+            </a:r>
+            <a:r>
+              <a:rPr sz="2400" spc="-20" dirty="0">
+                <a:solidFill>
+                  <a:srgbClr val="231F20"/>
+                </a:solidFill>
+                <a:latin typeface="Arial"/>
+                <a:cs typeface="Arial"/>
+              </a:rPr>
+              <a:t> </a:t>
+            </a:r>
+            <a:r>
+              <a:rPr sz="2400" dirty="0">
+                <a:solidFill>
+                  <a:srgbClr val="231F20"/>
+                </a:solidFill>
+                <a:latin typeface="Arial"/>
+                <a:cs typeface="Arial"/>
+              </a:rPr>
+              <a:t>the</a:t>
+            </a:r>
+            <a:r>
+              <a:rPr sz="2400" spc="-15" dirty="0">
+                <a:solidFill>
+                  <a:srgbClr val="231F20"/>
+                </a:solidFill>
+                <a:latin typeface="Arial"/>
+                <a:cs typeface="Arial"/>
+              </a:rPr>
+              <a:t> </a:t>
+            </a:r>
+            <a:r>
+              <a:rPr sz="2400" spc="-5" dirty="0">
+                <a:solidFill>
+                  <a:srgbClr val="231F20"/>
+                </a:solidFill>
+                <a:latin typeface="Arial"/>
+                <a:cs typeface="Arial"/>
+              </a:rPr>
+              <a:t>economy</a:t>
+            </a:r>
+            <a:r>
+              <a:rPr sz="2400" spc="-20" dirty="0">
+                <a:solidFill>
+                  <a:srgbClr val="231F20"/>
+                </a:solidFill>
+                <a:latin typeface="Arial"/>
+                <a:cs typeface="Arial"/>
+              </a:rPr>
+              <a:t> </a:t>
+            </a:r>
+            <a:r>
+              <a:rPr sz="2400" dirty="0">
+                <a:solidFill>
+                  <a:srgbClr val="231F20"/>
+                </a:solidFill>
+                <a:latin typeface="Arial"/>
+                <a:cs typeface="Arial"/>
+              </a:rPr>
+              <a:t>from</a:t>
+            </a:r>
+            <a:r>
+              <a:rPr sz="2400" spc="-15" dirty="0">
+                <a:solidFill>
+                  <a:srgbClr val="231F20"/>
+                </a:solidFill>
+                <a:latin typeface="Arial"/>
+                <a:cs typeface="Arial"/>
+              </a:rPr>
+              <a:t> </a:t>
+            </a:r>
+            <a:r>
+              <a:rPr sz="2400" dirty="0">
+                <a:solidFill>
+                  <a:srgbClr val="231F20"/>
+                </a:solidFill>
+                <a:latin typeface="Arial"/>
+                <a:cs typeface="Arial"/>
+              </a:rPr>
+              <a:t>the</a:t>
+            </a:r>
+            <a:r>
+              <a:rPr sz="2400" spc="-15" dirty="0">
+                <a:solidFill>
+                  <a:srgbClr val="231F20"/>
+                </a:solidFill>
+                <a:latin typeface="Arial"/>
+                <a:cs typeface="Arial"/>
+              </a:rPr>
+              <a:t> </a:t>
+            </a:r>
+            <a:r>
+              <a:rPr sz="2400" spc="-5" dirty="0">
+                <a:solidFill>
+                  <a:srgbClr val="231F20"/>
+                </a:solidFill>
+                <a:latin typeface="Arial"/>
+                <a:cs typeface="Arial"/>
+              </a:rPr>
+              <a:t>bottom-up.</a:t>
+            </a:r>
+            <a:endParaRPr sz="2400" dirty="0">
+              <a:latin typeface="Arial"/>
+              <a:cs typeface="Arial"/>
+            </a:endParaRPr>
+          </a:p>
+        </p:txBody>
+      </p:sp>
+      <p:sp>
+        <p:nvSpPr>
+          <p:cNvPr id="4" name="object 4"/>
+          <p:cNvSpPr txBox="1">
+            <a:spLocks noGrp="1"/>
+          </p:cNvSpPr>
+          <p:nvPr>
+            <p:ph type="sldNum" sz="quarter" idx="7"/>
+          </p:nvPr>
+        </p:nvSpPr>
+        <p:spPr>
+          <a:prstGeom prst="rect">
+            <a:avLst/>
+          </a:prstGeom>
+        </p:spPr>
+        <p:txBody>
+          <a:bodyPr vert="horz" wrap="square" lIns="0" tIns="0" rIns="0" bIns="0" rtlCol="0">
+            <a:spAutoFit/>
+          </a:bodyPr>
+          <a:lstStyle/>
+          <a:p>
+            <a:pPr marL="12700">
+              <a:lnSpc>
+                <a:spcPts val="1425"/>
+              </a:lnSpc>
+            </a:pPr>
+            <a:r>
+              <a:rPr spc="-5" dirty="0"/>
+              <a:t>page</a:t>
+            </a:r>
+            <a:r>
+              <a:rPr spc="-50" dirty="0"/>
+              <a:t> </a:t>
+            </a:r>
+            <a:fld id="{81D60167-4931-47E6-BA6A-407CBD079E47}" type="slidenum">
+              <a:rPr dirty="0"/>
+              <a:t>37</a:t>
+            </a:fld>
+            <a:endParaRPr dirty="0"/>
+          </a:p>
+        </p:txBody>
+      </p:sp>
+      <p:sp>
+        <p:nvSpPr>
+          <p:cNvPr id="3" name="object 3"/>
+          <p:cNvSpPr txBox="1">
+            <a:spLocks noGrp="1"/>
+          </p:cNvSpPr>
+          <p:nvPr>
+            <p:ph type="title"/>
+          </p:nvPr>
+        </p:nvSpPr>
+        <p:spPr>
+          <a:xfrm>
+            <a:off x="972819" y="933624"/>
+            <a:ext cx="5217160" cy="574040"/>
+          </a:xfrm>
+          <a:prstGeom prst="rect">
+            <a:avLst/>
+          </a:prstGeom>
+        </p:spPr>
+        <p:txBody>
+          <a:bodyPr vert="horz" wrap="square" lIns="0" tIns="12700" rIns="0" bIns="0" rtlCol="0">
+            <a:spAutoFit/>
+          </a:bodyPr>
+          <a:lstStyle/>
+          <a:p>
+            <a:pPr marL="12700">
+              <a:lnSpc>
+                <a:spcPct val="100000"/>
+              </a:lnSpc>
+              <a:spcBef>
+                <a:spcPts val="100"/>
+              </a:spcBef>
+            </a:pPr>
+            <a:r>
+              <a:rPr spc="25" dirty="0"/>
+              <a:t>Agent-based</a:t>
+            </a:r>
+            <a:r>
+              <a:rPr spc="-25" dirty="0"/>
+              <a:t> </a:t>
+            </a:r>
+            <a:r>
+              <a:rPr spc="35" dirty="0"/>
+              <a:t>Modeling</a:t>
+            </a:r>
+          </a:p>
+        </p:txBody>
+      </p:sp>
+    </p:spTree>
+    <p:extLst>
+      <p:ext uri="{BB962C8B-B14F-4D97-AF65-F5344CB8AC3E}">
+        <p14:creationId xmlns:p14="http://schemas.microsoft.com/office/powerpoint/2010/main" val="3898592652"/>
       </p:ext>
     </p:extLst>
   </p:cSld>
@@ -21963,14 +21467,617 @@
       </p:grpSpPr>
       <p:sp>
         <p:nvSpPr>
-          <p:cNvPr id="2" name="Title 1">
-            <a:extLst>
-              <a:ext uri="{FF2B5EF4-FFF2-40B4-BE49-F238E27FC236}">
-                <a16:creationId xmlns:a16="http://schemas.microsoft.com/office/drawing/2014/main" id="{CC0C084E-0F75-6BFB-2842-9EE57130CE36}"/>
-              </a:ext>
-            </a:extLst>
-          </p:cNvPr>
-          <p:cNvSpPr>
+          <p:cNvPr id="2" name="object 2"/>
+          <p:cNvSpPr txBox="1"/>
+          <p:nvPr/>
+        </p:nvSpPr>
+        <p:spPr>
+          <a:xfrm>
+            <a:off x="1282700" y="1821868"/>
+            <a:ext cx="6494145" cy="3683000"/>
+          </a:xfrm>
+          <a:prstGeom prst="rect">
+            <a:avLst/>
+          </a:prstGeom>
+        </p:spPr>
+        <p:txBody>
+          <a:bodyPr vert="horz" wrap="square" lIns="0" tIns="12700" rIns="0" bIns="0" rtlCol="0">
+            <a:spAutoFit/>
+          </a:bodyPr>
+          <a:lstStyle/>
+          <a:p>
+            <a:pPr marL="12700" marR="6985">
+              <a:lnSpc>
+                <a:spcPct val="100000"/>
+              </a:lnSpc>
+              <a:spcBef>
+                <a:spcPts val="100"/>
+              </a:spcBef>
+              <a:tabLst>
+                <a:tab pos="883919" algn="l"/>
+                <a:tab pos="2635250" algn="l"/>
+                <a:tab pos="4133215" algn="l"/>
+                <a:tab pos="5970270" algn="l"/>
+              </a:tabLst>
+            </a:pPr>
+            <a:r>
+              <a:rPr sz="2400" dirty="0">
+                <a:solidFill>
+                  <a:srgbClr val="231F20"/>
+                </a:solidFill>
+                <a:latin typeface="Arial"/>
+                <a:cs typeface="Arial"/>
+              </a:rPr>
+              <a:t>The	</a:t>
+            </a:r>
+            <a:r>
+              <a:rPr sz="2400" spc="-5" dirty="0">
+                <a:solidFill>
+                  <a:srgbClr val="231F20"/>
+                </a:solidFill>
+                <a:latin typeface="Arial"/>
+                <a:cs typeface="Arial"/>
+              </a:rPr>
+              <a:t>interactio</a:t>
+            </a:r>
+            <a:r>
+              <a:rPr sz="2400" dirty="0">
+                <a:solidFill>
+                  <a:srgbClr val="231F20"/>
+                </a:solidFill>
+                <a:latin typeface="Arial"/>
+                <a:cs typeface="Arial"/>
+              </a:rPr>
+              <a:t>n	</a:t>
+            </a:r>
+            <a:r>
+              <a:rPr sz="2400" spc="-5" dirty="0">
+                <a:solidFill>
+                  <a:srgbClr val="231F20"/>
+                </a:solidFill>
+                <a:latin typeface="Arial"/>
+                <a:cs typeface="Arial"/>
+              </a:rPr>
+              <a:t>betwee</a:t>
+            </a:r>
+            <a:r>
+              <a:rPr sz="2400" dirty="0">
+                <a:solidFill>
+                  <a:srgbClr val="231F20"/>
+                </a:solidFill>
+                <a:latin typeface="Arial"/>
+                <a:cs typeface="Arial"/>
+              </a:rPr>
+              <a:t>n	consumers	</a:t>
+            </a:r>
+            <a:r>
+              <a:rPr sz="2400" spc="-5" dirty="0">
+                <a:solidFill>
+                  <a:srgbClr val="231F20"/>
+                </a:solidFill>
+                <a:latin typeface="Arial"/>
+                <a:cs typeface="Arial"/>
+              </a:rPr>
+              <a:t>and  producers.</a:t>
+            </a:r>
+            <a:endParaRPr sz="2400">
+              <a:latin typeface="Arial"/>
+              <a:cs typeface="Arial"/>
+            </a:endParaRPr>
+          </a:p>
+          <a:p>
+            <a:pPr>
+              <a:lnSpc>
+                <a:spcPct val="100000"/>
+              </a:lnSpc>
+              <a:spcBef>
+                <a:spcPts val="5"/>
+              </a:spcBef>
+            </a:pPr>
+            <a:endParaRPr sz="2500">
+              <a:latin typeface="Arial"/>
+              <a:cs typeface="Arial"/>
+            </a:endParaRPr>
+          </a:p>
+          <a:p>
+            <a:pPr marL="12700" marR="278765">
+              <a:lnSpc>
+                <a:spcPct val="100000"/>
+              </a:lnSpc>
+            </a:pPr>
+            <a:r>
+              <a:rPr sz="2400" spc="-5" dirty="0">
+                <a:solidFill>
+                  <a:srgbClr val="231F20"/>
+                </a:solidFill>
+                <a:latin typeface="Arial"/>
+                <a:cs typeface="Arial"/>
+              </a:rPr>
+              <a:t>Consumer decision </a:t>
+            </a:r>
+            <a:r>
+              <a:rPr sz="2400" dirty="0">
+                <a:solidFill>
+                  <a:srgbClr val="231F20"/>
+                </a:solidFill>
+                <a:latin typeface="Arial"/>
+                <a:cs typeface="Arial"/>
+              </a:rPr>
+              <a:t>making: WTP </a:t>
+            </a:r>
+            <a:r>
+              <a:rPr sz="2400" spc="-45" dirty="0">
+                <a:solidFill>
+                  <a:srgbClr val="231F20"/>
+                </a:solidFill>
+                <a:latin typeface="Arial"/>
+                <a:cs typeface="Arial"/>
+              </a:rPr>
+              <a:t>v.s. </a:t>
+            </a:r>
+            <a:r>
+              <a:rPr sz="2400" spc="-5" dirty="0">
+                <a:solidFill>
+                  <a:srgbClr val="231F20"/>
+                </a:solidFill>
+                <a:latin typeface="Arial"/>
+                <a:cs typeface="Arial"/>
+              </a:rPr>
+              <a:t>price </a:t>
+            </a:r>
+            <a:r>
+              <a:rPr sz="2400" dirty="0">
+                <a:solidFill>
+                  <a:srgbClr val="231F20"/>
+                </a:solidFill>
+                <a:latin typeface="Arial"/>
+                <a:cs typeface="Arial"/>
+              </a:rPr>
+              <a:t> Producer</a:t>
+            </a:r>
+            <a:r>
+              <a:rPr sz="2400" spc="-15" dirty="0">
+                <a:solidFill>
+                  <a:srgbClr val="231F20"/>
+                </a:solidFill>
+                <a:latin typeface="Arial"/>
+                <a:cs typeface="Arial"/>
+              </a:rPr>
+              <a:t> </a:t>
+            </a:r>
+            <a:r>
+              <a:rPr sz="2400" spc="-5" dirty="0">
+                <a:solidFill>
+                  <a:srgbClr val="231F20"/>
+                </a:solidFill>
+                <a:latin typeface="Arial"/>
+                <a:cs typeface="Arial"/>
+              </a:rPr>
+              <a:t>decision</a:t>
+            </a:r>
+            <a:r>
+              <a:rPr sz="2400" spc="-20" dirty="0">
+                <a:solidFill>
+                  <a:srgbClr val="231F20"/>
+                </a:solidFill>
+                <a:latin typeface="Arial"/>
+                <a:cs typeface="Arial"/>
+              </a:rPr>
+              <a:t> </a:t>
+            </a:r>
+            <a:r>
+              <a:rPr sz="2400" dirty="0">
+                <a:solidFill>
+                  <a:srgbClr val="231F20"/>
+                </a:solidFill>
+                <a:latin typeface="Arial"/>
+                <a:cs typeface="Arial"/>
+              </a:rPr>
+              <a:t>making:</a:t>
+            </a:r>
+            <a:r>
+              <a:rPr sz="2400" spc="-15" dirty="0">
+                <a:solidFill>
+                  <a:srgbClr val="231F20"/>
+                </a:solidFill>
+                <a:latin typeface="Arial"/>
+                <a:cs typeface="Arial"/>
+              </a:rPr>
+              <a:t> </a:t>
+            </a:r>
+            <a:r>
+              <a:rPr sz="2400" spc="-5" dirty="0">
+                <a:solidFill>
+                  <a:srgbClr val="231F20"/>
+                </a:solidFill>
+                <a:latin typeface="Arial"/>
+                <a:cs typeface="Arial"/>
+              </a:rPr>
+              <a:t>opp.</a:t>
+            </a:r>
+            <a:r>
+              <a:rPr sz="2400" spc="-20" dirty="0">
+                <a:solidFill>
+                  <a:srgbClr val="231F20"/>
+                </a:solidFill>
+                <a:latin typeface="Arial"/>
+                <a:cs typeface="Arial"/>
+              </a:rPr>
+              <a:t> </a:t>
+            </a:r>
+            <a:r>
+              <a:rPr sz="2400" dirty="0">
+                <a:solidFill>
+                  <a:srgbClr val="231F20"/>
+                </a:solidFill>
+                <a:latin typeface="Arial"/>
+                <a:cs typeface="Arial"/>
+              </a:rPr>
+              <a:t>cost</a:t>
+            </a:r>
+            <a:r>
+              <a:rPr sz="2400" spc="-10" dirty="0">
+                <a:solidFill>
+                  <a:srgbClr val="231F20"/>
+                </a:solidFill>
+                <a:latin typeface="Arial"/>
+                <a:cs typeface="Arial"/>
+              </a:rPr>
+              <a:t> </a:t>
+            </a:r>
+            <a:r>
+              <a:rPr sz="2400" spc="-45" dirty="0">
+                <a:solidFill>
+                  <a:srgbClr val="231F20"/>
+                </a:solidFill>
+                <a:latin typeface="Arial"/>
+                <a:cs typeface="Arial"/>
+              </a:rPr>
+              <a:t>v.s.</a:t>
+            </a:r>
+            <a:r>
+              <a:rPr sz="2400" spc="-15" dirty="0">
+                <a:solidFill>
+                  <a:srgbClr val="231F20"/>
+                </a:solidFill>
+                <a:latin typeface="Arial"/>
+                <a:cs typeface="Arial"/>
+              </a:rPr>
+              <a:t> </a:t>
+            </a:r>
+            <a:r>
+              <a:rPr sz="2400" spc="-5" dirty="0">
+                <a:solidFill>
+                  <a:srgbClr val="231F20"/>
+                </a:solidFill>
+                <a:latin typeface="Arial"/>
+                <a:cs typeface="Arial"/>
+              </a:rPr>
+              <a:t>price</a:t>
+            </a:r>
+            <a:endParaRPr sz="2400">
+              <a:latin typeface="Arial"/>
+              <a:cs typeface="Arial"/>
+            </a:endParaRPr>
+          </a:p>
+          <a:p>
+            <a:pPr>
+              <a:lnSpc>
+                <a:spcPct val="100000"/>
+              </a:lnSpc>
+              <a:spcBef>
+                <a:spcPts val="5"/>
+              </a:spcBef>
+            </a:pPr>
+            <a:endParaRPr sz="2500">
+              <a:latin typeface="Arial"/>
+              <a:cs typeface="Arial"/>
+            </a:endParaRPr>
+          </a:p>
+          <a:p>
+            <a:pPr marL="12700">
+              <a:lnSpc>
+                <a:spcPct val="100000"/>
+              </a:lnSpc>
+            </a:pPr>
+            <a:r>
+              <a:rPr sz="2400" dirty="0">
+                <a:solidFill>
+                  <a:srgbClr val="231F20"/>
+                </a:solidFill>
+                <a:latin typeface="Arial"/>
+                <a:cs typeface="Arial"/>
+              </a:rPr>
+              <a:t>Interaction:</a:t>
+            </a:r>
+            <a:r>
+              <a:rPr sz="2400" spc="-25" dirty="0">
+                <a:solidFill>
+                  <a:srgbClr val="231F20"/>
+                </a:solidFill>
+                <a:latin typeface="Arial"/>
+                <a:cs typeface="Arial"/>
+              </a:rPr>
+              <a:t> </a:t>
+            </a:r>
+            <a:r>
+              <a:rPr sz="2400" dirty="0">
+                <a:solidFill>
+                  <a:srgbClr val="231F20"/>
+                </a:solidFill>
+                <a:latin typeface="Arial"/>
+                <a:cs typeface="Arial"/>
+              </a:rPr>
+              <a:t>the</a:t>
+            </a:r>
+            <a:r>
+              <a:rPr sz="2400" spc="-25" dirty="0">
+                <a:solidFill>
+                  <a:srgbClr val="231F20"/>
+                </a:solidFill>
+                <a:latin typeface="Arial"/>
+                <a:cs typeface="Arial"/>
+              </a:rPr>
+              <a:t> </a:t>
+            </a:r>
+            <a:r>
+              <a:rPr sz="2400" dirty="0">
+                <a:solidFill>
+                  <a:srgbClr val="231F20"/>
+                </a:solidFill>
+                <a:latin typeface="Arial"/>
+                <a:cs typeface="Arial"/>
+              </a:rPr>
+              <a:t>market</a:t>
+            </a:r>
+            <a:r>
+              <a:rPr sz="2400" spc="-25" dirty="0">
+                <a:solidFill>
+                  <a:srgbClr val="231F20"/>
+                </a:solidFill>
+                <a:latin typeface="Arial"/>
+                <a:cs typeface="Arial"/>
+              </a:rPr>
+              <a:t> </a:t>
+            </a:r>
+            <a:r>
+              <a:rPr sz="2400" dirty="0">
+                <a:solidFill>
+                  <a:srgbClr val="231F20"/>
+                </a:solidFill>
+                <a:latin typeface="Arial"/>
+                <a:cs typeface="Arial"/>
+              </a:rPr>
+              <a:t>mechanism</a:t>
+            </a:r>
+            <a:endParaRPr sz="2400">
+              <a:latin typeface="Arial"/>
+              <a:cs typeface="Arial"/>
+            </a:endParaRPr>
+          </a:p>
+          <a:p>
+            <a:pPr>
+              <a:lnSpc>
+                <a:spcPct val="100000"/>
+              </a:lnSpc>
+              <a:spcBef>
+                <a:spcPts val="5"/>
+              </a:spcBef>
+            </a:pPr>
+            <a:endParaRPr sz="2500">
+              <a:latin typeface="Arial"/>
+              <a:cs typeface="Arial"/>
+            </a:endParaRPr>
+          </a:p>
+          <a:p>
+            <a:pPr marL="12700" marR="5080">
+              <a:lnSpc>
+                <a:spcPct val="100000"/>
+              </a:lnSpc>
+            </a:pPr>
+            <a:r>
+              <a:rPr sz="2400" dirty="0">
+                <a:solidFill>
+                  <a:srgbClr val="231F20"/>
+                </a:solidFill>
+                <a:latin typeface="Arial"/>
+                <a:cs typeface="Arial"/>
+              </a:rPr>
+              <a:t>Outcome:</a:t>
+            </a:r>
+            <a:r>
+              <a:rPr sz="2400" spc="55" dirty="0">
+                <a:solidFill>
+                  <a:srgbClr val="231F20"/>
+                </a:solidFill>
+                <a:latin typeface="Arial"/>
+                <a:cs typeface="Arial"/>
+              </a:rPr>
+              <a:t> </a:t>
+            </a:r>
+            <a:r>
+              <a:rPr sz="2400" dirty="0">
+                <a:solidFill>
+                  <a:srgbClr val="231F20"/>
+                </a:solidFill>
+                <a:latin typeface="Arial"/>
+                <a:cs typeface="Arial"/>
+              </a:rPr>
+              <a:t>market</a:t>
+            </a:r>
+            <a:r>
+              <a:rPr sz="2400" spc="50" dirty="0">
+                <a:solidFill>
+                  <a:srgbClr val="231F20"/>
+                </a:solidFill>
+                <a:latin typeface="Arial"/>
+                <a:cs typeface="Arial"/>
+              </a:rPr>
+              <a:t> </a:t>
+            </a:r>
+            <a:r>
+              <a:rPr sz="2400" dirty="0">
+                <a:solidFill>
+                  <a:srgbClr val="231F20"/>
+                </a:solidFill>
+                <a:latin typeface="Arial"/>
+                <a:cs typeface="Arial"/>
+              </a:rPr>
+              <a:t>status</a:t>
+            </a:r>
+            <a:r>
+              <a:rPr sz="2400" spc="50" dirty="0">
+                <a:solidFill>
+                  <a:srgbClr val="231F20"/>
+                </a:solidFill>
+                <a:latin typeface="Arial"/>
+                <a:cs typeface="Arial"/>
+              </a:rPr>
+              <a:t> </a:t>
+            </a:r>
+            <a:r>
+              <a:rPr sz="2400" dirty="0">
+                <a:solidFill>
+                  <a:srgbClr val="231F20"/>
+                </a:solidFill>
+                <a:latin typeface="Arial"/>
+                <a:cs typeface="Arial"/>
+              </a:rPr>
+              <a:t>(i.e.,</a:t>
+            </a:r>
+            <a:r>
+              <a:rPr sz="2400" spc="50" dirty="0">
+                <a:solidFill>
+                  <a:srgbClr val="231F20"/>
+                </a:solidFill>
+                <a:latin typeface="Arial"/>
+                <a:cs typeface="Arial"/>
+              </a:rPr>
+              <a:t> </a:t>
+            </a:r>
+            <a:r>
+              <a:rPr sz="2400" dirty="0">
+                <a:solidFill>
+                  <a:srgbClr val="231F20"/>
+                </a:solidFill>
+                <a:latin typeface="Arial"/>
+                <a:cs typeface="Arial"/>
+              </a:rPr>
+              <a:t>shortage,</a:t>
+            </a:r>
+            <a:r>
+              <a:rPr sz="2400" spc="50" dirty="0">
+                <a:solidFill>
+                  <a:srgbClr val="231F20"/>
+                </a:solidFill>
+                <a:latin typeface="Arial"/>
+                <a:cs typeface="Arial"/>
+              </a:rPr>
+              <a:t> </a:t>
+            </a:r>
+            <a:r>
+              <a:rPr sz="2400" dirty="0">
+                <a:solidFill>
+                  <a:srgbClr val="231F20"/>
+                </a:solidFill>
+                <a:latin typeface="Arial"/>
+                <a:cs typeface="Arial"/>
+              </a:rPr>
+              <a:t>surplus, </a:t>
+            </a:r>
+            <a:r>
+              <a:rPr sz="2400" spc="-655" dirty="0">
+                <a:solidFill>
+                  <a:srgbClr val="231F20"/>
+                </a:solidFill>
+                <a:latin typeface="Arial"/>
+                <a:cs typeface="Arial"/>
+              </a:rPr>
+              <a:t> </a:t>
+            </a:r>
+            <a:r>
+              <a:rPr sz="2400" spc="-5" dirty="0">
+                <a:solidFill>
+                  <a:srgbClr val="231F20"/>
+                </a:solidFill>
+                <a:latin typeface="Arial"/>
+                <a:cs typeface="Arial"/>
+              </a:rPr>
+              <a:t>or</a:t>
+            </a:r>
+            <a:r>
+              <a:rPr sz="2400" spc="-10" dirty="0">
+                <a:solidFill>
+                  <a:srgbClr val="231F20"/>
+                </a:solidFill>
+                <a:latin typeface="Arial"/>
+                <a:cs typeface="Arial"/>
+              </a:rPr>
+              <a:t> </a:t>
+            </a:r>
+            <a:r>
+              <a:rPr sz="2400" spc="-5" dirty="0">
+                <a:solidFill>
+                  <a:srgbClr val="231F20"/>
+                </a:solidFill>
+                <a:latin typeface="Arial"/>
+                <a:cs typeface="Arial"/>
+              </a:rPr>
+              <a:t>equilibrium)</a:t>
+            </a:r>
+            <a:endParaRPr sz="2400">
+              <a:latin typeface="Arial"/>
+              <a:cs typeface="Arial"/>
+            </a:endParaRPr>
+          </a:p>
+        </p:txBody>
+      </p:sp>
+      <p:sp>
+        <p:nvSpPr>
+          <p:cNvPr id="4" name="object 4"/>
+          <p:cNvSpPr txBox="1">
+            <a:spLocks noGrp="1"/>
+          </p:cNvSpPr>
+          <p:nvPr>
+            <p:ph type="sldNum" sz="quarter" idx="7"/>
+          </p:nvPr>
+        </p:nvSpPr>
+        <p:spPr>
+          <a:prstGeom prst="rect">
+            <a:avLst/>
+          </a:prstGeom>
+        </p:spPr>
+        <p:txBody>
+          <a:bodyPr vert="horz" wrap="square" lIns="0" tIns="0" rIns="0" bIns="0" rtlCol="0">
+            <a:spAutoFit/>
+          </a:bodyPr>
+          <a:lstStyle/>
+          <a:p>
+            <a:pPr marL="12700">
+              <a:lnSpc>
+                <a:spcPts val="1425"/>
+              </a:lnSpc>
+            </a:pPr>
+            <a:r>
+              <a:rPr spc="-5" dirty="0"/>
+              <a:t>page</a:t>
+            </a:r>
+            <a:r>
+              <a:rPr spc="-50" dirty="0"/>
+              <a:t> </a:t>
+            </a:r>
+            <a:fld id="{81D60167-4931-47E6-BA6A-407CBD079E47}" type="slidenum">
+              <a:rPr dirty="0"/>
+              <a:t>38</a:t>
+            </a:fld>
+            <a:endParaRPr dirty="0"/>
+          </a:p>
+        </p:txBody>
+      </p:sp>
+      <p:sp>
+        <p:nvSpPr>
+          <p:cNvPr id="3" name="object 3"/>
+          <p:cNvSpPr txBox="1">
             <a:spLocks noGrp="1"/>
           </p:cNvSpPr>
           <p:nvPr>
@@ -21979,135 +22086,38 @@
         </p:nvSpPr>
         <p:spPr>
           <a:xfrm>
-            <a:off x="990600" y="914400"/>
-            <a:ext cx="7806689" cy="574040"/>
+            <a:off x="972819" y="933624"/>
+            <a:ext cx="5217160" cy="574040"/>
           </a:xfrm>
+          <a:prstGeom prst="rect">
+            <a:avLst/>
+          </a:prstGeom>
         </p:spPr>
         <p:txBody>
-          <a:bodyPr/>
+          <a:bodyPr vert="horz" wrap="square" lIns="0" tIns="12700" rIns="0" bIns="0" rtlCol="0">
+            <a:spAutoFit/>
+          </a:bodyPr>
           <a:lstStyle/>
           <a:p>
-            <a:r>
-              <a:rPr lang="en-US" dirty="0"/>
-              <a:t>Project</a:t>
-            </a:r>
-          </a:p>
-        </p:txBody>
-      </p:sp>
-      <p:sp>
-        <p:nvSpPr>
-          <p:cNvPr id="3" name="Text Placeholder 2">
-            <a:extLst>
-              <a:ext uri="{FF2B5EF4-FFF2-40B4-BE49-F238E27FC236}">
-                <a16:creationId xmlns:a16="http://schemas.microsoft.com/office/drawing/2014/main" id="{A723667F-DC69-554E-329F-38B4F426F9DA}"/>
-              </a:ext>
-            </a:extLst>
-          </p:cNvPr>
-          <p:cNvSpPr>
-            <a:spLocks noGrp="1"/>
-          </p:cNvSpPr>
-          <p:nvPr>
-            <p:ph type="body" idx="1"/>
-          </p:nvPr>
-        </p:nvSpPr>
-        <p:spPr>
-          <a:xfrm>
-            <a:off x="990601" y="1730428"/>
-            <a:ext cx="7086600" cy="4062651"/>
-          </a:xfrm>
-        </p:spPr>
-        <p:txBody>
-          <a:bodyPr/>
-          <a:lstStyle/>
-          <a:p>
-            <a:r>
-              <a:rPr lang="en-US" dirty="0"/>
-              <a:t>In this project, you will apply object-oriented programing technique to simulate the market demand/supply model.</a:t>
-            </a:r>
-          </a:p>
-          <a:p>
-            <a:endParaRPr lang="en-US" dirty="0"/>
-          </a:p>
-          <a:p>
-            <a:pPr marL="342900" indent="-342900">
-              <a:buClr>
-                <a:srgbClr val="0070C0"/>
-              </a:buClr>
-              <a:buFont typeface="Arial" panose="020B0604020202020204" pitchFamily="34" charset="0"/>
-              <a:buChar char="•"/>
+            <a:pPr marL="12700">
+              <a:lnSpc>
+                <a:spcPct val="100000"/>
+              </a:lnSpc>
+              <a:spcBef>
+                <a:spcPts val="100"/>
+              </a:spcBef>
             </a:pPr>
             <a:r>
-              <a:rPr lang="en-US" dirty="0"/>
-              <a:t>Define “agent” as an abstract concept</a:t>
-            </a:r>
-          </a:p>
-          <a:p>
-            <a:pPr marL="342900" indent="-342900">
-              <a:buClr>
-                <a:srgbClr val="0070C0"/>
-              </a:buClr>
-              <a:buFont typeface="Arial" panose="020B0604020202020204" pitchFamily="34" charset="0"/>
-              <a:buChar char="•"/>
-            </a:pPr>
-            <a:endParaRPr lang="en-US" dirty="0"/>
-          </a:p>
-          <a:p>
-            <a:pPr marL="342900" indent="-342900">
-              <a:buClr>
-                <a:srgbClr val="0070C0"/>
-              </a:buClr>
-              <a:buFont typeface="Arial" panose="020B0604020202020204" pitchFamily="34" charset="0"/>
-              <a:buChar char="•"/>
-            </a:pPr>
-            <a:r>
-              <a:rPr lang="en-US" dirty="0"/>
-              <a:t>Create child classes under the “agent”</a:t>
-            </a:r>
-          </a:p>
-          <a:p>
-            <a:pPr marL="342900" indent="-342900">
-              <a:buClr>
-                <a:srgbClr val="0070C0"/>
-              </a:buClr>
-              <a:buFont typeface="Arial" panose="020B0604020202020204" pitchFamily="34" charset="0"/>
-              <a:buChar char="•"/>
-            </a:pPr>
-            <a:endParaRPr lang="en-US" dirty="0"/>
-          </a:p>
-          <a:p>
-            <a:pPr marL="342900" indent="-342900">
-              <a:buClr>
-                <a:srgbClr val="0070C0"/>
-              </a:buClr>
-              <a:buFont typeface="Arial" panose="020B0604020202020204" pitchFamily="34" charset="0"/>
-              <a:buChar char="•"/>
-            </a:pPr>
-            <a:r>
-              <a:rPr lang="en-US" dirty="0"/>
-              <a:t>Instantiate “consumer” and “producer” as objects and have them interact on a simulated “market”</a:t>
-            </a:r>
-          </a:p>
-          <a:p>
-            <a:pPr marL="342900" indent="-342900">
-              <a:buClr>
-                <a:srgbClr val="0070C0"/>
-              </a:buClr>
-              <a:buFont typeface="Arial" panose="020B0604020202020204" pitchFamily="34" charset="0"/>
-              <a:buChar char="•"/>
-            </a:pPr>
-            <a:endParaRPr lang="en-US" dirty="0"/>
-          </a:p>
-          <a:p>
-            <a:pPr marL="342900" indent="-342900">
-              <a:buClr>
-                <a:srgbClr val="0070C0"/>
-              </a:buClr>
-              <a:buFont typeface="Arial" panose="020B0604020202020204" pitchFamily="34" charset="0"/>
-              <a:buChar char="•"/>
-            </a:pPr>
-            <a:r>
-              <a:rPr lang="en-US" dirty="0"/>
-              <a:t>Simulate the process of finding market equilibrium</a:t>
+              <a:rPr spc="25" dirty="0"/>
+              <a:t>Agent-based</a:t>
+            </a:r>
+            <a:r>
+              <a:rPr spc="-25" dirty="0"/>
+              <a:t> </a:t>
+            </a:r>
+            <a:r>
+              <a:rPr spc="35" dirty="0"/>
+              <a:t>Modeling</a:t>
             </a:r>
           </a:p>
         </p:txBody>
@@ -22115,7 +22125,7 @@
     </p:spTree>
     <p:extLst>
       <p:ext uri="{BB962C8B-B14F-4D97-AF65-F5344CB8AC3E}">
-        <p14:creationId xmlns:p14="http://schemas.microsoft.com/office/powerpoint/2010/main" val="1691547658"/>
+        <p14:creationId xmlns:p14="http://schemas.microsoft.com/office/powerpoint/2010/main" val="322501022"/>
       </p:ext>
     </p:extLst>
   </p:cSld>

</xml_diff>